<commit_message>
Fix Module 1 supporting-file friction: merge cm-profil-dapur-rara.txt into cm-template-kompetitor.txt as one self-contained, pre-filled Dapur Rara example (business + 3 fictional competitors + ready prompt + expected-result reference + brand voice), so students without their own business don't have to invent competitor data to do the exercise. Students with their own business now edit the same file in place instead of using a separate blank template. Updated HTML copy (Yang Kamu Butuhkan, step-row, Latihan, Output), PPTX slides 4-5, and course outline xlsx to match. Fixed stale 'Modul 2 sampai 7'/'Modul 7 Capstone' references left over from before the two-course split.
</commit_message>
<xml_diff>
--- a/Content-Marketing/M01-Positioning-Kompetitor/K3-M01-Positioning-Kompetitor.pptx
+++ b/Content-Marketing/M01-Positioning-Kompetitor/K3-M01-Positioning-Kompetitor.pptx
@@ -3338,7 +3338,7 @@
                 <a:ea typeface="Arial" pitchFamily="34" charset="-122"/>
                 <a:cs typeface="Arial" pitchFamily="34" charset="-120"/>
               </a:rPr>
-              <a:t>Isi Data Kompetitor —  </a:t>
+              <a:t>Punya Bisnis Sendiri? —  </a:t>
             </a:r>
             <a:pPr indent="0" marL="0">
               <a:lnSpc>
@@ -3355,7 +3355,7 @@
                 <a:ea typeface="Arial" pitchFamily="34" charset="-122"/>
                 <a:cs typeface="Arial" pitchFamily="34" charset="-120"/>
               </a:rPr>
-              <a:t>cm-template-kompetitor.txt dengan harga, rating, dan 10 ulasan paling buruk 3 kompetitor</a:t>
+              <a:t>ganti data kompetitor di cm-template-kompetitor.txt — harga, rating, ulasan terburuk 3 kompetitor nyata. Pakai contoh Dapur Rara? Lewati ke langkah 3</a:t>
             </a:r>
             <a:endParaRPr lang="en-US" sz="1300" dirty="0"/>
           </a:p>
@@ -3456,7 +3456,7 @@
                 <a:ea typeface="Arial" pitchFamily="34" charset="-122"/>
                 <a:cs typeface="Arial" pitchFamily="34" charset="-120"/>
               </a:rPr>
-              <a:t>Isi Data Bisnismu —  </a:t>
+              <a:t>Ganti Data Bisnismu —  </a:t>
             </a:r>
             <a:pPr indent="0" marL="0">
               <a:lnSpc>
@@ -3473,7 +3473,7 @@
                 <a:ea typeface="Arial" pitchFamily="34" charset="-122"/>
                 <a:cs typeface="Arial" pitchFamily="34" charset="-120"/>
               </a:rPr>
-              <a:t>tanya 3 pelanggan lama kenapa mereka beli, termasuk palet warna &amp; mood visual</a:t>
+              <a:t>isi juga palet warna &amp; mood visual — tanya 3 pelanggan lama kenapa mereka beli dari kamu</a:t>
             </a:r>
             <a:endParaRPr lang="en-US" sz="1300" dirty="0"/>
           </a:p>
@@ -3591,7 +3591,7 @@
                 <a:ea typeface="Arial" pitchFamily="34" charset="-122"/>
                 <a:cs typeface="Arial" pitchFamily="34" charset="-120"/>
               </a:rPr>
-              <a:t>paste seluruh template ke Claude dengan prompt di atas</a:t>
+              <a:t>paste seluruh file ke Claude dengan prompt yang sudah ada di dalamnya</a:t>
             </a:r>
             <a:endParaRPr lang="en-US" sz="1300" dirty="0"/>
           </a:p>
@@ -4263,7 +4263,7 @@
                 <a:ea typeface="Arial" pitchFamily="34" charset="-122"/>
                 <a:cs typeface="Arial" pitchFamily="34" charset="-120"/>
               </a:rPr>
-              <a:t>Download dan isi cm-template-kompetitor.txt dengan data 3 kompetitor nyata bisnismu, termasuk palet warna dan mood/gaya visual. Paste ke Claude dan minta analisis SWOT + gap + 3 variasi kalimat positioning. Pilih satu, simpan profil lengkap di Claude Projects — ini akan dipakai di Modul 2 sampai 5.</a:t>
+              <a:t>Download cm-template-kompetitor.txt — sudah terisi contoh Dapur Rara, langsung paste ke Claude untuk latihan. Punya bisnis sendiri? Ganti dulu semua datanya (termasuk palet warna dan mood/gaya visual) sebelum paste. Minta Claude analisis SWOT + gap + 3 variasi kalimat positioning. Pilih satu, simpan profil lengkap di Claude Projects — ini akan dipakai di Modul 2 sampai 5.</a:t>
             </a:r>
             <a:endParaRPr lang="en-US" sz="1250" dirty="0"/>
           </a:p>
@@ -4400,7 +4400,7 @@
                 <a:ea typeface="Arial" pitchFamily="34" charset="-122"/>
                 <a:cs typeface="Arial" pitchFamily="34" charset="-120"/>
               </a:rPr>
-              <a:t>File pendukung: cm-template-kompetitor.txt (atau cm-profil-dapur-rara.txt sebagai contoh)</a:t>
+              <a:t>File pendukung: cm-template-kompetitor.txt (sudah terisi contoh Dapur Rara, edit untuk bisnismu sendiri)</a:t>
             </a:r>
             <a:endParaRPr lang="en-US" sz="1250" dirty="0"/>
           </a:p>

</xml_diff>

<commit_message>
Fix step-card layout bug + clarify paste-boundary in Module 1 competitor template
- Fix flex:1 stretching lone wrapped step-card to full width (content-marketing,
  strategi-marketing, produktivitas content pages)
- Add explicit PASTE KE CLAUDE boundary markers to cm-template-kompetitor.txt
  so students know exactly what to copy vs. what's reference-only
- Reorder Module 1: move color/mood tip-box before step-by-step section
- Update PPTX + xlsx wording to match new paste-boundary language
</commit_message>
<xml_diff>
--- a/Content-Marketing/M01-Positioning-Kompetitor/K3-M01-Positioning-Kompetitor.pptx
+++ b/Content-Marketing/M01-Positioning-Kompetitor/K3-M01-Positioning-Kompetitor.pptx
@@ -2953,7 +2953,7 @@
                 <a:ea typeface="Arial" pitchFamily="34" charset="-122"/>
                 <a:cs typeface="Arial" pitchFamily="34" charset="-120"/>
               </a:rPr>
-              <a:t>"Ini data 3 kompetitor frozen food saya [paste isi cm-template-kompetitor.txt]. Buatkan: SWOT singkat, gap yang belum diisi kompetitor manapun, dan 1 kalimat positioning: Untuk [siapa], [bisnis] adalah [apa] yang [benefit] karena [bukti]."</a:t>
+              <a:t>"Ini data 3 kompetitor frozen food saya [paste bagian PASTE KE CLAUDE dari cm-template-kompetitor.txt]. Buatkan: SWOT singkat, gap yang belum diisi kompetitor manapun, dan 1 kalimat positioning: Untuk [siapa], [bisnis] adalah [apa] yang [benefit] karena [bukti]."</a:t>
             </a:r>
             <a:endParaRPr lang="en-US" sz="1150" dirty="0"/>
           </a:p>
@@ -3591,7 +3591,7 @@
                 <a:ea typeface="Arial" pitchFamily="34" charset="-122"/>
                 <a:cs typeface="Arial" pitchFamily="34" charset="-120"/>
               </a:rPr>
-              <a:t>paste seluruh file ke Claude dengan prompt yang sudah ada di dalamnya</a:t>
+              <a:t>copy bagian yang ditandai PASTE KE CLAUDE saja (bukan seluruh file) — prompt sudah ada di dalamnya</a:t>
             </a:r>
             <a:endParaRPr lang="en-US" sz="1300" dirty="0"/>
           </a:p>
@@ -4263,7 +4263,7 @@
                 <a:ea typeface="Arial" pitchFamily="34" charset="-122"/>
                 <a:cs typeface="Arial" pitchFamily="34" charset="-120"/>
               </a:rPr>
-              <a:t>Download cm-template-kompetitor.txt — sudah terisi contoh Dapur Rara, langsung paste ke Claude untuk latihan. Punya bisnis sendiri? Ganti dulu semua datanya (termasuk palet warna dan mood/gaya visual) sebelum paste. Minta Claude analisis SWOT + gap + 3 variasi kalimat positioning. Pilih satu, simpan profil lengkap di Claude Projects — ini akan dipakai di Modul 2 sampai 5.</a:t>
+              <a:t>Buka cm-template-kompetitor.txt — sudah terisi contoh Dapur Rara. Punya bisnis sendiri? Ganti dulu Data Bisnis dan Data Kompetitor di dalamnya (termasuk palet warna dan mood/gaya visual). Copy bagian yang ditandai PASTE KE CLAUDE saja ke Claude — bagian di bawahnya hanya referensi, jangan ikut di-paste. Minta analisis SWOT + gap + 3 variasi kalimat positioning. Pilih satu, simpan profil lengkap di Claude Projects — ini akan dipakai di Modul 2 sampai 5.</a:t>
             </a:r>
             <a:endParaRPr lang="en-US" sz="1250" dirty="0"/>
           </a:p>

</xml_diff>

<commit_message>
Apply Julia's slide 3 card-height tightening to M1 PPTX
She'd manually shortened the PROMPT BURUK/PROMPT BAIK card boxes on slide 3
in PowerPoint (3.6in -> ~2.7in) to remove excess bottom whitespace. Folded
that into build_m01_pptx.js (addPromptCard h: 3.6 -> 2.7) so it's preserved
alongside the Checkpoint 69 wording fixes, which her local copy predated.
</commit_message>
<xml_diff>
--- a/Content-Marketing/M01-Positioning-Kompetitor/K3-M01-Positioning-Kompetitor.pptx
+++ b/Content-Marketing/M01-Positioning-Kompetitor/K3-M01-Positioning-Kompetitor.pptx
@@ -2710,11 +2710,11 @@
         <p:spPr>
           <a:xfrm>
             <a:off x="548640" y="2148840"/>
-            <a:ext cx="5413248" cy="3291840"/>
+            <a:ext cx="5413248" cy="2468880"/>
           </a:xfrm>
           <a:prstGeom prst="roundRect">
             <a:avLst>
-              <a:gd name="adj" fmla="val 2222"/>
+              <a:gd name="adj" fmla="val 2963"/>
             </a:avLst>
           </a:prstGeom>
           <a:solidFill>
@@ -2776,7 +2776,7 @@
         <p:spPr>
           <a:xfrm>
             <a:off x="749808" y="2651760"/>
-            <a:ext cx="5010912" cy="2240280"/>
+            <a:ext cx="5010912" cy="1417320"/>
           </a:xfrm>
           <a:prstGeom prst="rect">
             <a:avLst/>
@@ -2817,7 +2817,7 @@
         </p:nvSpPr>
         <p:spPr>
           <a:xfrm>
-            <a:off x="749808" y="4873752"/>
+            <a:off x="749808" y="4050792"/>
             <a:ext cx="5010912" cy="457200"/>
           </a:xfrm>
           <a:prstGeom prst="rect">
@@ -2860,11 +2860,11 @@
         <p:spPr>
           <a:xfrm>
             <a:off x="6227064" y="2148840"/>
-            <a:ext cx="5413248" cy="3291840"/>
+            <a:ext cx="5413248" cy="2468880"/>
           </a:xfrm>
           <a:prstGeom prst="roundRect">
             <a:avLst>
-              <a:gd name="adj" fmla="val 2222"/>
+              <a:gd name="adj" fmla="val 2963"/>
             </a:avLst>
           </a:prstGeom>
           <a:solidFill>
@@ -2926,7 +2926,7 @@
         <p:spPr>
           <a:xfrm>
             <a:off x="6428232" y="2651760"/>
-            <a:ext cx="5010912" cy="2240280"/>
+            <a:ext cx="5010912" cy="1417320"/>
           </a:xfrm>
           <a:prstGeom prst="rect">
             <a:avLst/>
@@ -2967,7 +2967,7 @@
         </p:nvSpPr>
         <p:spPr>
           <a:xfrm>
-            <a:off x="6428232" y="4873752"/>
+            <a:off x="6428232" y="4050792"/>
             <a:ext cx="5010912" cy="457200"/>
           </a:xfrm>
           <a:prstGeom prst="rect">

</xml_diff>

<commit_message>
Sync M01 + M05 PPTX from local (source of truth) — M01 slide-1 subtitle restores '10 menit' suffix
</commit_message>
<xml_diff>
--- a/Content-Marketing/M01-Positioning-Kompetitor/K3-M01-Positioning-Kompetitor.pptx
+++ b/Content-Marketing/M01-Positioning-Kompetitor/K3-M01-Positioning-Kompetitor.pptx
@@ -4,6 +4,9 @@
   <p:sldMasterIdLst>
     <p:sldMasterId id="2147483648" r:id="rId1"/>
   </p:sldMasterIdLst>
+  <p:notesMasterIdLst>
+    <p:notesMasterId r:id="rId7"/>
+  </p:notesMasterIdLst>
   <p:sldIdLst>
     <p:sldId id="256" r:id="rId2"/>
     <p:sldId id="257" r:id="rId3"/>
@@ -11,11 +14,8 @@
     <p:sldId id="259" r:id="rId5"/>
     <p:sldId id="260" r:id="rId6"/>
   </p:sldIdLst>
-  <p:notesMasterIdLst>
-    <p:notesMasterId r:id="rId7"/>
-  </p:notesMasterIdLst>
-  <p:sldSz cx="12191695" cy="6858000"/>
-  <p:notesSz cx="6858000" cy="12191695"/>
+  <p:sldSz cx="12192000" cy="6858000"/>
+  <p:notesSz cx="6858000" cy="12192000"/>
   <p:defaultTextStyle>
     <a:lvl1pPr marL="0" algn="l" defTabSz="914400" rtl="0" eaLnBrk="1" latinLnBrk="0" hangingPunct="1">
       <a:defRPr sz="1800" kern="1200">
@@ -108,6 +108,11 @@
       </a:defRPr>
     </a:lvl9pPr>
   </p:defaultTextStyle>
+  <p:extLst>
+    <p:ext uri="{EFAFB233-063F-42B5-8137-9DF3F51BA10A}">
+      <p15:sldGuideLst xmlns:p15="http://schemas.microsoft.com/office/powerpoint/2012/main"/>
+    </p:ext>
+  </p:extLst>
 </p:presentation>
 </file>
 
@@ -133,234 +138,10 @@
           <a:chExt cx="0" cy="0"/>
         </a:xfrm>
       </p:grpSpPr>
-      <p:sp>
-        <p:nvSpPr>
-          <p:cNvPr id="2" name="Header Placeholder 1"/>
-          <p:cNvSpPr>
-            <a:spLocks noGrp="1"/>
-          </p:cNvSpPr>
-          <p:nvPr>
-            <p:ph type="hdr" sz="quarter"/>
-          </p:nvPr>
-        </p:nvSpPr>
-        <p:spPr>
-          <a:xfrm>
-            <a:off x="0" y="0"/>
-            <a:ext cx="2971800" cy="458788"/>
-          </a:xfrm>
-          <a:prstGeom prst="rect">
-            <a:avLst/>
-          </a:prstGeom>
-        </p:spPr>
-        <p:txBody>
-          <a:bodyPr vert="horz" lIns="91440" tIns="45720" rIns="91440" bIns="45720" rtlCol="0"/>
-          <a:lstStyle>
-            <a:lvl1pPr algn="l">
-              <a:defRPr sz="1200"/>
-            </a:lvl1pPr>
-          </a:lstStyle>
-          <a:p>
-            <a:endParaRPr lang="en-US"/>
-          </a:p>
-        </p:txBody>
-      </p:sp>
-      <p:sp>
-        <p:nvSpPr>
-          <p:cNvPr id="3" name="Date Placeholder 2"/>
-          <p:cNvSpPr>
-            <a:spLocks noGrp="1"/>
-          </p:cNvSpPr>
-          <p:nvPr>
-            <p:ph type="dt" idx="1"/>
-          </p:nvPr>
-        </p:nvSpPr>
-        <p:spPr>
-          <a:xfrm>
-            <a:off x="3884613" y="0"/>
-            <a:ext cx="2971800" cy="458788"/>
-          </a:xfrm>
-          <a:prstGeom prst="rect">
-            <a:avLst/>
-          </a:prstGeom>
-        </p:spPr>
-        <p:txBody>
-          <a:bodyPr vert="horz" lIns="91440" tIns="45720" rIns="91440" bIns="45720" rtlCol="0"/>
-          <a:lstStyle>
-            <a:lvl1pPr algn="r">
-              <a:defRPr sz="1200"/>
-            </a:lvl1pPr>
-          </a:lstStyle>
-          <a:p>
-            <a:fld id="{5282F153-3F37-0F45-9E97-73ACFA13230C}" type="datetimeFigureOut">
-              <a:rPr lang="en-US"/>
-              <a:t>7/23/19</a:t>
-            </a:fld>
-            <a:endParaRPr lang="en-US"/>
-          </a:p>
-        </p:txBody>
-      </p:sp>
-      <p:sp>
-        <p:nvSpPr>
-          <p:cNvPr id="4" name="Slide Image Placeholder 3"/>
-          <p:cNvSpPr>
-            <a:spLocks noGrp="1" noRot="1" noChangeAspect="1"/>
-          </p:cNvSpPr>
-          <p:nvPr>
-            <p:ph type="sldImg" idx="2"/>
-          </p:nvPr>
-        </p:nvSpPr>
-        <p:spPr>
-          <a:xfrm>
-            <a:off x="685800" y="1143000"/>
-            <a:ext cx="5486400" cy="3086100"/>
-          </a:xfrm>
-          <a:prstGeom prst="rect">
-            <a:avLst/>
-          </a:prstGeom>
-          <a:noFill/>
-          <a:ln w="12700">
-            <a:solidFill>
-              <a:prstClr val="black"/>
-            </a:solidFill>
-          </a:ln>
-        </p:spPr>
-        <p:txBody>
-          <a:bodyPr vert="horz" lIns="91440" tIns="45720" rIns="91440" bIns="45720" rtlCol="0" anchor="ctr"/>
-          <a:lstStyle/>
-          <a:p>
-            <a:endParaRPr lang="en-US"/>
-          </a:p>
-        </p:txBody>
-      </p:sp>
-      <p:sp>
-        <p:nvSpPr>
-          <p:cNvPr id="5" name="Notes Placeholder 4"/>
-          <p:cNvSpPr>
-            <a:spLocks noGrp="1"/>
-          </p:cNvSpPr>
-          <p:nvPr>
-            <p:ph type="body" sz="quarter" idx="3"/>
-          </p:nvPr>
-        </p:nvSpPr>
-        <p:spPr>
-          <a:xfrm>
-            <a:off x="685800" y="4400550"/>
-            <a:ext cx="5486400" cy="3600450"/>
-          </a:xfrm>
-          <a:prstGeom prst="rect">
-            <a:avLst/>
-          </a:prstGeom>
-        </p:spPr>
-        <p:txBody>
-          <a:bodyPr vert="horz" lIns="91440" tIns="45720" rIns="91440" bIns="45720" rtlCol="0"/>
-          <a:lstStyle/>
-          <a:p>
-            <a:pPr lvl="0"/>
-            <a:r>
-              <a:rPr lang="en-US"/>
-              <a:t>Click to edit Master text styles</a:t>
-            </a:r>
-          </a:p>
-          <a:p>
-            <a:pPr lvl="1"/>
-            <a:r>
-              <a:rPr lang="en-US"/>
-              <a:t>Second level</a:t>
-            </a:r>
-          </a:p>
-          <a:p>
-            <a:pPr lvl="2"/>
-            <a:r>
-              <a:rPr lang="en-US"/>
-              <a:t>Third level</a:t>
-            </a:r>
-          </a:p>
-          <a:p>
-            <a:pPr lvl="3"/>
-            <a:r>
-              <a:rPr lang="en-US"/>
-              <a:t>Fourth level</a:t>
-            </a:r>
-          </a:p>
-          <a:p>
-            <a:pPr lvl="4"/>
-            <a:r>
-              <a:rPr lang="en-US"/>
-              <a:t>Fifth level</a:t>
-            </a:r>
-          </a:p>
-        </p:txBody>
-      </p:sp>
-      <p:sp>
-        <p:nvSpPr>
-          <p:cNvPr id="6" name="Footer Placeholder 5"/>
-          <p:cNvSpPr>
-            <a:spLocks noGrp="1"/>
-          </p:cNvSpPr>
-          <p:nvPr>
-            <p:ph type="ftr" sz="quarter" idx="4"/>
-          </p:nvPr>
-        </p:nvSpPr>
-        <p:spPr>
-          <a:xfrm>
-            <a:off x="0" y="8685213"/>
-            <a:ext cx="2971800" cy="458787"/>
-          </a:xfrm>
-          <a:prstGeom prst="rect">
-            <a:avLst/>
-          </a:prstGeom>
-        </p:spPr>
-        <p:txBody>
-          <a:bodyPr vert="horz" lIns="91440" tIns="45720" rIns="91440" bIns="45720" rtlCol="0" anchor="b"/>
-          <a:lstStyle>
-            <a:lvl1pPr algn="l">
-              <a:defRPr sz="1200"/>
-            </a:lvl1pPr>
-          </a:lstStyle>
-          <a:p>
-            <a:endParaRPr lang="en-US"/>
-          </a:p>
-        </p:txBody>
-      </p:sp>
-      <p:sp>
-        <p:nvSpPr>
-          <p:cNvPr id="7" name="Slide Number Placeholder 6"/>
-          <p:cNvSpPr>
-            <a:spLocks noGrp="1"/>
-          </p:cNvSpPr>
-          <p:nvPr>
-            <p:ph type="sldNum" sz="quarter" idx="5"/>
-          </p:nvPr>
-        </p:nvSpPr>
-        <p:spPr>
-          <a:xfrm>
-            <a:off x="3884613" y="8685213"/>
-            <a:ext cx="2971800" cy="458787"/>
-          </a:xfrm>
-          <a:prstGeom prst="rect">
-            <a:avLst/>
-          </a:prstGeom>
-        </p:spPr>
-        <p:txBody>
-          <a:bodyPr vert="horz" lIns="91440" tIns="45720" rIns="91440" bIns="45720" rtlCol="0" anchor="b"/>
-          <a:lstStyle>
-            <a:lvl1pPr algn="r">
-              <a:defRPr sz="1200"/>
-            </a:lvl1pPr>
-          </a:lstStyle>
-          <a:p>
-            <a:fld id="{CE5E9CC1-C706-0F49-92D6-E571CC5EEA8F}" type="slidenum">
-              <a:rPr lang="en-US"/>
-              <a:t>‹#›</a:t>
-            </a:fld>
-            <a:endParaRPr lang="en-US"/>
-          </a:p>
-        </p:txBody>
-      </p:sp>
     </p:spTree>
     <p:extLst>
       <p:ext uri="{BB962C8B-B14F-4D97-AF65-F5344CB8AC3E}">
-        <p14:creationId xmlns:p14="http://schemas.microsoft.com/office/powerpoint/2010/main" val="1024086991"/>
+        <p14:creationId xmlns:p14="http://schemas.microsoft.com/office/powerpoint/2010/main" val="3142775447"/>
       </p:ext>
     </p:extLst>
   </p:cSld>
@@ -504,10 +285,6 @@
           <a:bodyPr/>
           <a:lstStyle/>
           <a:p>
-            <a:r>
-              <a:rPr lang="en-US" dirty="0"/>
-              <a:t/>
-            </a:r>
             <a:endParaRPr lang="en-US" dirty="0"/>
           </a:p>
         </p:txBody>
@@ -592,10 +369,6 @@
           <a:bodyPr/>
           <a:lstStyle/>
           <a:p>
-            <a:r>
-              <a:rPr lang="en-US" dirty="0"/>
-              <a:t/>
-            </a:r>
             <a:endParaRPr lang="en-US" dirty="0"/>
           </a:p>
         </p:txBody>
@@ -680,10 +453,6 @@
           <a:bodyPr/>
           <a:lstStyle/>
           <a:p>
-            <a:r>
-              <a:rPr lang="en-US" dirty="0"/>
-              <a:t/>
-            </a:r>
             <a:endParaRPr lang="en-US" dirty="0"/>
           </a:p>
         </p:txBody>
@@ -768,10 +537,6 @@
           <a:bodyPr/>
           <a:lstStyle/>
           <a:p>
-            <a:r>
-              <a:rPr lang="en-US" dirty="0"/>
-              <a:t/>
-            </a:r>
             <a:endParaRPr lang="en-US" dirty="0"/>
           </a:p>
         </p:txBody>
@@ -856,10 +621,6 @@
           <a:bodyPr/>
           <a:lstStyle/>
           <a:p>
-            <a:r>
-              <a:rPr lang="en-US" dirty="0"/>
-              <a:t/>
-            </a:r>
             <a:endParaRPr lang="en-US" dirty="0"/>
           </a:p>
         </p:txBody>
@@ -933,6 +694,11 @@
 <file path=ppt/slideMasters/slideMaster1.xml><?xml version="1.0" encoding="utf-8"?>
 <p:sldMaster xmlns:a="http://schemas.openxmlformats.org/drawingml/2006/main" xmlns:r="http://schemas.openxmlformats.org/officeDocument/2006/relationships" xmlns:p="http://schemas.openxmlformats.org/presentationml/2006/main">
   <p:cSld>
+    <p:bg>
+      <p:bgRef idx="1001">
+        <a:schemeClr val="bg1"/>
+      </p:bgRef>
+    </p:bg>
     <p:spTree>
       <p:nvGrpSpPr>
         <p:cNvPr id="1" name=""/>
@@ -1215,6 +981,7 @@
         <a:solidFill>
           <a:srgbClr val="FFFFFF"/>
         </a:solidFill>
+        <a:effectLst/>
       </p:bgPr>
     </p:bg>
     <p:spTree>
@@ -1250,6 +1017,13 @@
           </a:solidFill>
           <a:ln/>
         </p:spPr>
+        <p:txBody>
+          <a:bodyPr/>
+          <a:lstStyle/>
+          <a:p>
+            <a:endParaRPr lang="en-ID"/>
+          </a:p>
+        </p:txBody>
       </p:sp>
       <p:sp>
         <p:nvSpPr>
@@ -1270,6 +1044,13 @@
           </a:solidFill>
           <a:ln/>
         </p:spPr>
+        <p:txBody>
+          <a:bodyPr/>
+          <a:lstStyle/>
+          <a:p>
+            <a:endParaRPr lang="en-ID"/>
+          </a:p>
+        </p:txBody>
       </p:sp>
       <p:sp>
         <p:nvSpPr>
@@ -1292,7 +1073,7 @@
           <a:bodyPr wrap="square" lIns="0" tIns="0" rIns="0" bIns="0" rtlCol="0" anchor="ctr"/>
           <a:lstStyle/>
           <a:p>
-            <a:pPr indent="0" marL="0">
+            <a:pPr marL="0" indent="0">
               <a:buNone/>
             </a:pPr>
             <a:r>
@@ -1306,9 +1087,6 @@
               </a:rPr>
               <a:t>belajar</a:t>
             </a:r>
-            <a:pPr indent="0" marL="0">
-              <a:buNone/>
-            </a:pPr>
             <a:r>
               <a:rPr lang="en-US" sz="2000" b="1" dirty="0">
                 <a:solidFill>
@@ -1345,6 +1123,13 @@
           </a:solidFill>
           <a:ln/>
         </p:spPr>
+        <p:txBody>
+          <a:bodyPr/>
+          <a:lstStyle/>
+          <a:p>
+            <a:endParaRPr lang="en-ID"/>
+          </a:p>
+        </p:txBody>
       </p:sp>
       <p:sp>
         <p:nvSpPr>
@@ -1367,7 +1152,7 @@
           <a:bodyPr wrap="square" lIns="0" tIns="0" rIns="0" bIns="0" rtlCol="0" anchor="ctr"/>
           <a:lstStyle/>
           <a:p>
-            <a:pPr algn="ctr" indent="0" marL="0">
+            <a:pPr marL="0" indent="0" algn="ctr">
               <a:buNone/>
             </a:pPr>
             <a:r>
@@ -1406,11 +1191,11 @@
           <a:bodyPr wrap="square" lIns="0" tIns="0" rIns="0" bIns="0" rtlCol="0" anchor="ctr"/>
           <a:lstStyle/>
           <a:p>
-            <a:pPr indent="0" marL="0">
-              <a:buNone/>
-            </a:pPr>
-            <a:r>
-              <a:rPr lang="en-US" sz="1300" b="1" spc="100" kern="0" dirty="0">
+            <a:pPr marL="0" indent="0">
+              <a:buNone/>
+            </a:pPr>
+            <a:r>
+              <a:rPr lang="en-US" sz="1300" b="1" kern="0" spc="100" dirty="0">
                 <a:solidFill>
                   <a:srgbClr val="8B7CF6"/>
                 </a:solidFill>
@@ -1445,7 +1230,7 @@
           <a:bodyPr wrap="square" lIns="0" tIns="0" rIns="0" bIns="0" rtlCol="0" anchor="ctr"/>
           <a:lstStyle/>
           <a:p>
-            <a:pPr indent="0" marL="0">
+            <a:pPr marL="0" indent="0">
               <a:buNone/>
             </a:pPr>
             <a:r>
@@ -1484,7 +1269,7 @@
           <a:bodyPr wrap="square" lIns="0" tIns="0" rIns="0" bIns="0" rtlCol="0" anchor="ctr"/>
           <a:lstStyle/>
           <a:p>
-            <a:pPr indent="0" marL="0">
+            <a:pPr marL="0" indent="0">
               <a:buNone/>
             </a:pPr>
             <a:r>
@@ -1496,7 +1281,40 @@
                 <a:ea typeface="Arial" pitchFamily="34" charset="-122"/>
                 <a:cs typeface="Arial" pitchFamily="34" charset="-120"/>
               </a:rPr>
-              <a:t>Untuk siapa produk ini, dan kenapa harus pilih kamu — 10 menit</a:t>
+              <a:t>Untuk siapa produk ini, dan kenapa harus </a:t>
+            </a:r>
+            <a:r>
+              <a:rPr lang="en-US" sz="1550" dirty="0" err="1">
+                <a:solidFill>
+                  <a:srgbClr val="B7C0D8"/>
+                </a:solidFill>
+                <a:latin typeface="Arial" pitchFamily="34" charset="0"/>
+                <a:ea typeface="Arial" pitchFamily="34" charset="-122"/>
+                <a:cs typeface="Arial" pitchFamily="34" charset="-120"/>
+              </a:rPr>
+              <a:t>pilih</a:t>
+            </a:r>
+            <a:r>
+              <a:rPr lang="en-US" sz="1550" dirty="0">
+                <a:solidFill>
+                  <a:srgbClr val="B7C0D8"/>
+                </a:solidFill>
+                <a:latin typeface="Arial" pitchFamily="34" charset="0"/>
+                <a:ea typeface="Arial" pitchFamily="34" charset="-122"/>
+                <a:cs typeface="Arial" pitchFamily="34" charset="-120"/>
+              </a:rPr>
+              <a:t> </a:t>
+            </a:r>
+            <a:r>
+              <a:rPr lang="en-US" sz="1550" dirty="0" err="1">
+                <a:solidFill>
+                  <a:srgbClr val="B7C0D8"/>
+                </a:solidFill>
+                <a:latin typeface="Arial" pitchFamily="34" charset="0"/>
+                <a:ea typeface="Arial" pitchFamily="34" charset="-122"/>
+                <a:cs typeface="Arial" pitchFamily="34" charset="-120"/>
+              </a:rPr>
+              <a:t>kamu — 10 menit</a:t>
             </a:r>
             <a:endParaRPr lang="en-US" sz="1550" dirty="0"/>
           </a:p>
@@ -1518,6 +1336,7 @@
         <a:solidFill>
           <a:srgbClr val="FFFFFF"/>
         </a:solidFill>
+        <a:effectLst/>
       </p:bgPr>
     </p:bg>
     <p:spTree>
@@ -1553,6 +1372,13 @@
           </a:solidFill>
           <a:ln/>
         </p:spPr>
+        <p:txBody>
+          <a:bodyPr/>
+          <a:lstStyle/>
+          <a:p>
+            <a:endParaRPr lang="en-ID"/>
+          </a:p>
+        </p:txBody>
       </p:sp>
       <p:sp>
         <p:nvSpPr>
@@ -1573,6 +1399,13 @@
           </a:solidFill>
           <a:ln/>
         </p:spPr>
+        <p:txBody>
+          <a:bodyPr/>
+          <a:lstStyle/>
+          <a:p>
+            <a:endParaRPr lang="en-ID"/>
+          </a:p>
+        </p:txBody>
       </p:sp>
       <p:sp>
         <p:nvSpPr>
@@ -1595,7 +1428,7 @@
           <a:bodyPr wrap="square" lIns="0" tIns="0" rIns="0" bIns="0" rtlCol="0" anchor="ctr"/>
           <a:lstStyle/>
           <a:p>
-            <a:pPr indent="0" marL="0">
+            <a:pPr marL="0" indent="0">
               <a:buNone/>
             </a:pPr>
             <a:r>
@@ -1609,9 +1442,6 @@
               </a:rPr>
               <a:t>belajar</a:t>
             </a:r>
-            <a:pPr indent="0" marL="0">
-              <a:buNone/>
-            </a:pPr>
             <a:r>
               <a:rPr lang="en-US" sz="2000" b="1" dirty="0">
                 <a:solidFill>
@@ -1648,7 +1478,7 @@
           <a:bodyPr wrap="square" lIns="0" tIns="0" rIns="0" bIns="0" rtlCol="0" anchor="ctr"/>
           <a:lstStyle/>
           <a:p>
-            <a:pPr algn="r" indent="0" marL="0">
+            <a:pPr marL="0" indent="0" algn="r">
               <a:buNone/>
             </a:pPr>
             <a:r>
@@ -1687,11 +1517,11 @@
           <a:bodyPr wrap="square" lIns="0" tIns="0" rIns="0" bIns="0" rtlCol="0" anchor="ctr"/>
           <a:lstStyle/>
           <a:p>
-            <a:pPr indent="0" marL="0">
-              <a:buNone/>
-            </a:pPr>
-            <a:r>
-              <a:rPr lang="en-US" sz="1250" b="1" spc="100" kern="0" dirty="0">
+            <a:pPr marL="0" indent="0">
+              <a:buNone/>
+            </a:pPr>
+            <a:r>
+              <a:rPr lang="en-US" sz="1250" b="1" kern="0" spc="100" dirty="0">
                 <a:solidFill>
                   <a:srgbClr val="4B36C7"/>
                 </a:solidFill>
@@ -1726,7 +1556,7 @@
           <a:bodyPr wrap="square" lIns="0" tIns="0" rIns="0" bIns="0" rtlCol="0" anchor="ctr"/>
           <a:lstStyle/>
           <a:p>
-            <a:pPr indent="0" marL="0">
+            <a:pPr marL="0" indent="0">
               <a:buNone/>
             </a:pPr>
             <a:r>
@@ -1770,6 +1600,13 @@
             <a:prstDash val="solid"/>
           </a:ln>
         </p:spPr>
+        <p:txBody>
+          <a:bodyPr/>
+          <a:lstStyle/>
+          <a:p>
+            <a:endParaRPr lang="en-ID"/>
+          </a:p>
+        </p:txBody>
       </p:sp>
       <p:sp>
         <p:nvSpPr>
@@ -1792,11 +1629,11 @@
           <a:bodyPr wrap="square" lIns="0" tIns="0" rIns="0" bIns="0" rtlCol="0" anchor="ctr"/>
           <a:lstStyle/>
           <a:p>
-            <a:pPr indent="0" marL="0">
-              <a:buNone/>
-            </a:pPr>
-            <a:r>
-              <a:rPr lang="en-US" sz="1200" b="1" spc="50" kern="0" dirty="0">
+            <a:pPr marL="0" indent="0">
+              <a:buNone/>
+            </a:pPr>
+            <a:r>
+              <a:rPr lang="en-US" sz="1200" b="1" kern="0" spc="50" dirty="0">
                 <a:solidFill>
                   <a:srgbClr val="6B7280"/>
                 </a:solidFill>
@@ -1930,6 +1767,13 @@
             <a:prstDash val="solid"/>
           </a:ln>
         </p:spPr>
+        <p:txBody>
+          <a:bodyPr/>
+          <a:lstStyle/>
+          <a:p>
+            <a:endParaRPr lang="en-ID"/>
+          </a:p>
+        </p:txBody>
       </p:sp>
       <p:sp>
         <p:nvSpPr>
@@ -1952,11 +1796,11 @@
           <a:bodyPr wrap="square" lIns="0" tIns="0" rIns="0" bIns="0" rtlCol="0" anchor="ctr"/>
           <a:lstStyle/>
           <a:p>
-            <a:pPr indent="0" marL="0">
-              <a:buNone/>
-            </a:pPr>
-            <a:r>
-              <a:rPr lang="en-US" sz="1200" b="1" spc="50" kern="0" dirty="0">
+            <a:pPr marL="0" indent="0">
+              <a:buNone/>
+            </a:pPr>
+            <a:r>
+              <a:rPr lang="en-US" sz="1200" b="1" kern="0" spc="50" dirty="0">
                 <a:solidFill>
                   <a:srgbClr val="4B36C7"/>
                 </a:solidFill>
@@ -2085,11 +1929,11 @@
           <a:bodyPr wrap="square" lIns="0" tIns="0" rIns="0" bIns="0" rtlCol="0" anchor="ctr"/>
           <a:lstStyle/>
           <a:p>
-            <a:pPr indent="0" marL="0">
-              <a:buNone/>
-            </a:pPr>
-            <a:r>
-              <a:rPr lang="en-US" sz="1250" b="1" spc="50" kern="0" dirty="0">
+            <a:pPr marL="0" indent="0">
+              <a:buNone/>
+            </a:pPr>
+            <a:r>
+              <a:rPr lang="en-US" sz="1250" b="1" kern="0" spc="50" dirty="0">
                 <a:solidFill>
                   <a:srgbClr val="4B36C7"/>
                 </a:solidFill>
@@ -2129,6 +1973,13 @@
             <a:prstDash val="solid"/>
           </a:ln>
         </p:spPr>
+        <p:txBody>
+          <a:bodyPr/>
+          <a:lstStyle/>
+          <a:p>
+            <a:endParaRPr lang="en-ID"/>
+          </a:p>
+        </p:txBody>
       </p:sp>
       <p:sp>
         <p:nvSpPr>
@@ -2151,7 +2002,7 @@
           <a:bodyPr wrap="square" lIns="0" tIns="0" rIns="0" bIns="0" rtlCol="0" anchor="ctr"/>
           <a:lstStyle/>
           <a:p>
-            <a:pPr algn="ctr" indent="0" marL="0">
+            <a:pPr marL="0" indent="0" algn="ctr">
               <a:lnSpc>
                 <a:spcPct val="105000"/>
               </a:lnSpc>
@@ -2171,7 +2022,7 @@
             <a:endParaRPr lang="en-US" sz="1050" dirty="0"/>
           </a:p>
           <a:p>
-            <a:pPr algn="ctr" indent="0" marL="0">
+            <a:pPr marL="0" indent="0" algn="ctr">
               <a:lnSpc>
                 <a:spcPct val="105000"/>
               </a:lnSpc>
@@ -2218,6 +2069,13 @@
             <a:prstDash val="solid"/>
           </a:ln>
         </p:spPr>
+        <p:txBody>
+          <a:bodyPr/>
+          <a:lstStyle/>
+          <a:p>
+            <a:endParaRPr lang="en-ID"/>
+          </a:p>
+        </p:txBody>
       </p:sp>
       <p:sp>
         <p:nvSpPr>
@@ -2240,7 +2098,7 @@
           <a:bodyPr wrap="square" lIns="0" tIns="0" rIns="0" bIns="0" rtlCol="0" anchor="ctr"/>
           <a:lstStyle/>
           <a:p>
-            <a:pPr algn="ctr" indent="0" marL="0">
+            <a:pPr marL="0" indent="0" algn="ctr">
               <a:lnSpc>
                 <a:spcPct val="105000"/>
               </a:lnSpc>
@@ -2260,7 +2118,7 @@
             <a:endParaRPr lang="en-US" sz="1050" dirty="0"/>
           </a:p>
           <a:p>
-            <a:pPr algn="ctr" indent="0" marL="0">
+            <a:pPr marL="0" indent="0" algn="ctr">
               <a:lnSpc>
                 <a:spcPct val="105000"/>
               </a:lnSpc>
@@ -2307,6 +2165,13 @@
             <a:prstDash val="solid"/>
           </a:ln>
         </p:spPr>
+        <p:txBody>
+          <a:bodyPr/>
+          <a:lstStyle/>
+          <a:p>
+            <a:endParaRPr lang="en-ID"/>
+          </a:p>
+        </p:txBody>
       </p:sp>
       <p:sp>
         <p:nvSpPr>
@@ -2329,7 +2194,7 @@
           <a:bodyPr wrap="square" lIns="0" tIns="0" rIns="0" bIns="0" rtlCol="0" anchor="ctr"/>
           <a:lstStyle/>
           <a:p>
-            <a:pPr algn="ctr" indent="0" marL="0">
+            <a:pPr marL="0" indent="0" algn="ctr">
               <a:lnSpc>
                 <a:spcPct val="105000"/>
               </a:lnSpc>
@@ -2349,7 +2214,7 @@
             <a:endParaRPr lang="en-US" sz="1050" dirty="0"/>
           </a:p>
           <a:p>
-            <a:pPr algn="ctr" indent="0" marL="0">
+            <a:pPr marL="0" indent="0" algn="ctr">
               <a:lnSpc>
                 <a:spcPct val="105000"/>
               </a:lnSpc>
@@ -2396,6 +2261,13 @@
             <a:prstDash val="solid"/>
           </a:ln>
         </p:spPr>
+        <p:txBody>
+          <a:bodyPr/>
+          <a:lstStyle/>
+          <a:p>
+            <a:endParaRPr lang="en-ID"/>
+          </a:p>
+        </p:txBody>
       </p:sp>
       <p:sp>
         <p:nvSpPr>
@@ -2418,7 +2290,7 @@
           <a:bodyPr wrap="square" lIns="0" tIns="0" rIns="0" bIns="0" rtlCol="0" anchor="ctr"/>
           <a:lstStyle/>
           <a:p>
-            <a:pPr algn="ctr" indent="0" marL="0">
+            <a:pPr marL="0" indent="0" algn="ctr">
               <a:lnSpc>
                 <a:spcPct val="105000"/>
               </a:lnSpc>
@@ -2438,7 +2310,7 @@
             <a:endParaRPr lang="en-US" sz="1050" dirty="0"/>
           </a:p>
           <a:p>
-            <a:pPr algn="ctr" indent="0" marL="0">
+            <a:pPr marL="0" indent="0" algn="ctr">
               <a:lnSpc>
                 <a:spcPct val="105000"/>
               </a:lnSpc>
@@ -2475,6 +2347,7 @@
         <a:solidFill>
           <a:srgbClr val="FFFFFF"/>
         </a:solidFill>
+        <a:effectLst/>
       </p:bgPr>
     </p:bg>
     <p:spTree>
@@ -2510,6 +2383,13 @@
           </a:solidFill>
           <a:ln/>
         </p:spPr>
+        <p:txBody>
+          <a:bodyPr/>
+          <a:lstStyle/>
+          <a:p>
+            <a:endParaRPr lang="en-ID"/>
+          </a:p>
+        </p:txBody>
       </p:sp>
       <p:sp>
         <p:nvSpPr>
@@ -2530,6 +2410,13 @@
           </a:solidFill>
           <a:ln/>
         </p:spPr>
+        <p:txBody>
+          <a:bodyPr/>
+          <a:lstStyle/>
+          <a:p>
+            <a:endParaRPr lang="en-ID"/>
+          </a:p>
+        </p:txBody>
       </p:sp>
       <p:sp>
         <p:nvSpPr>
@@ -2552,7 +2439,7 @@
           <a:bodyPr wrap="square" lIns="0" tIns="0" rIns="0" bIns="0" rtlCol="0" anchor="ctr"/>
           <a:lstStyle/>
           <a:p>
-            <a:pPr indent="0" marL="0">
+            <a:pPr marL="0" indent="0">
               <a:buNone/>
             </a:pPr>
             <a:r>
@@ -2566,9 +2453,6 @@
               </a:rPr>
               <a:t>belajar</a:t>
             </a:r>
-            <a:pPr indent="0" marL="0">
-              <a:buNone/>
-            </a:pPr>
             <a:r>
               <a:rPr lang="en-US" sz="2000" b="1" dirty="0">
                 <a:solidFill>
@@ -2605,7 +2489,7 @@
           <a:bodyPr wrap="square" lIns="0" tIns="0" rIns="0" bIns="0" rtlCol="0" anchor="ctr"/>
           <a:lstStyle/>
           <a:p>
-            <a:pPr algn="r" indent="0" marL="0">
+            <a:pPr marL="0" indent="0" algn="r">
               <a:buNone/>
             </a:pPr>
             <a:r>
@@ -2644,11 +2528,11 @@
           <a:bodyPr wrap="square" lIns="0" tIns="0" rIns="0" bIns="0" rtlCol="0" anchor="ctr"/>
           <a:lstStyle/>
           <a:p>
-            <a:pPr indent="0" marL="0">
-              <a:buNone/>
-            </a:pPr>
-            <a:r>
-              <a:rPr lang="en-US" sz="1250" b="1" spc="100" kern="0" dirty="0">
+            <a:pPr marL="0" indent="0">
+              <a:buNone/>
+            </a:pPr>
+            <a:r>
+              <a:rPr lang="en-US" sz="1250" b="1" kern="0" spc="100" dirty="0">
                 <a:solidFill>
                   <a:srgbClr val="4B36C7"/>
                 </a:solidFill>
@@ -2683,7 +2567,7 @@
           <a:bodyPr wrap="square" lIns="0" tIns="0" rIns="0" bIns="0" rtlCol="0" anchor="ctr"/>
           <a:lstStyle/>
           <a:p>
-            <a:pPr indent="0" marL="0">
+            <a:pPr marL="0" indent="0">
               <a:buNone/>
             </a:pPr>
             <a:r>
@@ -2727,6 +2611,13 @@
             <a:prstDash val="solid"/>
           </a:ln>
         </p:spPr>
+        <p:txBody>
+          <a:bodyPr/>
+          <a:lstStyle/>
+          <a:p>
+            <a:endParaRPr lang="en-ID"/>
+          </a:p>
+        </p:txBody>
       </p:sp>
       <p:sp>
         <p:nvSpPr>
@@ -2749,11 +2640,11 @@
           <a:bodyPr wrap="square" lIns="0" tIns="0" rIns="0" bIns="0" rtlCol="0" anchor="ctr"/>
           <a:lstStyle/>
           <a:p>
-            <a:pPr indent="0" marL="0">
-              <a:buNone/>
-            </a:pPr>
-            <a:r>
-              <a:rPr lang="en-US" sz="1200" b="1" spc="50" kern="0" dirty="0">
+            <a:pPr marL="0" indent="0">
+              <a:buNone/>
+            </a:pPr>
+            <a:r>
+              <a:rPr lang="en-US" sz="1200" b="1" kern="0" spc="50" dirty="0">
                 <a:solidFill>
                   <a:srgbClr val="6B7280"/>
                 </a:solidFill>
@@ -2788,7 +2679,7 @@
           <a:bodyPr wrap="square" lIns="0" tIns="0" rIns="0" bIns="0" rtlCol="0" anchor="t"/>
           <a:lstStyle/>
           <a:p>
-            <a:pPr indent="0" marL="0">
+            <a:pPr marL="0" indent="0">
               <a:lnSpc>
                 <a:spcPct val="115000"/>
               </a:lnSpc>
@@ -2830,7 +2721,7 @@
           <a:bodyPr wrap="square" lIns="0" tIns="0" rIns="0" bIns="0" rtlCol="0" anchor="t"/>
           <a:lstStyle/>
           <a:p>
-            <a:pPr indent="0" marL="0">
+            <a:pPr marL="0" indent="0">
               <a:lnSpc>
                 <a:spcPct val="110000"/>
               </a:lnSpc>
@@ -2877,6 +2768,13 @@
             <a:prstDash val="solid"/>
           </a:ln>
         </p:spPr>
+        <p:txBody>
+          <a:bodyPr/>
+          <a:lstStyle/>
+          <a:p>
+            <a:endParaRPr lang="en-ID"/>
+          </a:p>
+        </p:txBody>
       </p:sp>
       <p:sp>
         <p:nvSpPr>
@@ -2899,11 +2797,11 @@
           <a:bodyPr wrap="square" lIns="0" tIns="0" rIns="0" bIns="0" rtlCol="0" anchor="ctr"/>
           <a:lstStyle/>
           <a:p>
-            <a:pPr indent="0" marL="0">
-              <a:buNone/>
-            </a:pPr>
-            <a:r>
-              <a:rPr lang="en-US" sz="1200" b="1" spc="50" kern="0" dirty="0">
+            <a:pPr marL="0" indent="0">
+              <a:buNone/>
+            </a:pPr>
+            <a:r>
+              <a:rPr lang="en-US" sz="1200" b="1" kern="0" spc="50" dirty="0">
                 <a:solidFill>
                   <a:srgbClr val="4B36C7"/>
                 </a:solidFill>
@@ -2938,7 +2836,7 @@
           <a:bodyPr wrap="square" lIns="0" tIns="0" rIns="0" bIns="0" rtlCol="0" anchor="t"/>
           <a:lstStyle/>
           <a:p>
-            <a:pPr indent="0" marL="0">
+            <a:pPr marL="0" indent="0">
               <a:lnSpc>
                 <a:spcPct val="115000"/>
               </a:lnSpc>
@@ -2980,7 +2878,7 @@
           <a:bodyPr wrap="square" lIns="0" tIns="0" rIns="0" bIns="0" rtlCol="0" anchor="t"/>
           <a:lstStyle/>
           <a:p>
-            <a:pPr indent="0" marL="0">
+            <a:pPr marL="0" indent="0">
               <a:lnSpc>
                 <a:spcPct val="110000"/>
               </a:lnSpc>
@@ -3017,6 +2915,7 @@
         <a:solidFill>
           <a:srgbClr val="FFFFFF"/>
         </a:solidFill>
+        <a:effectLst/>
       </p:bgPr>
     </p:bg>
     <p:spTree>
@@ -3052,6 +2951,13 @@
           </a:solidFill>
           <a:ln/>
         </p:spPr>
+        <p:txBody>
+          <a:bodyPr/>
+          <a:lstStyle/>
+          <a:p>
+            <a:endParaRPr lang="en-ID"/>
+          </a:p>
+        </p:txBody>
       </p:sp>
       <p:sp>
         <p:nvSpPr>
@@ -3072,6 +2978,13 @@
           </a:solidFill>
           <a:ln/>
         </p:spPr>
+        <p:txBody>
+          <a:bodyPr/>
+          <a:lstStyle/>
+          <a:p>
+            <a:endParaRPr lang="en-ID"/>
+          </a:p>
+        </p:txBody>
       </p:sp>
       <p:sp>
         <p:nvSpPr>
@@ -3094,7 +3007,7 @@
           <a:bodyPr wrap="square" lIns="0" tIns="0" rIns="0" bIns="0" rtlCol="0" anchor="ctr"/>
           <a:lstStyle/>
           <a:p>
-            <a:pPr indent="0" marL="0">
+            <a:pPr marL="0" indent="0">
               <a:buNone/>
             </a:pPr>
             <a:r>
@@ -3108,9 +3021,6 @@
               </a:rPr>
               <a:t>belajar</a:t>
             </a:r>
-            <a:pPr indent="0" marL="0">
-              <a:buNone/>
-            </a:pPr>
             <a:r>
               <a:rPr lang="en-US" sz="2000" b="1" dirty="0">
                 <a:solidFill>
@@ -3147,7 +3057,7 @@
           <a:bodyPr wrap="square" lIns="0" tIns="0" rIns="0" bIns="0" rtlCol="0" anchor="ctr"/>
           <a:lstStyle/>
           <a:p>
-            <a:pPr algn="r" indent="0" marL="0">
+            <a:pPr marL="0" indent="0" algn="r">
               <a:buNone/>
             </a:pPr>
             <a:r>
@@ -3186,11 +3096,11 @@
           <a:bodyPr wrap="square" lIns="0" tIns="0" rIns="0" bIns="0" rtlCol="0" anchor="ctr"/>
           <a:lstStyle/>
           <a:p>
-            <a:pPr indent="0" marL="0">
-              <a:buNone/>
-            </a:pPr>
-            <a:r>
-              <a:rPr lang="en-US" sz="1250" b="1" spc="100" kern="0" dirty="0">
+            <a:pPr marL="0" indent="0">
+              <a:buNone/>
+            </a:pPr>
+            <a:r>
+              <a:rPr lang="en-US" sz="1250" b="1" kern="0" spc="100" dirty="0">
                 <a:solidFill>
                   <a:srgbClr val="4B36C7"/>
                 </a:solidFill>
@@ -3225,7 +3135,7 @@
           <a:bodyPr wrap="square" lIns="0" tIns="0" rIns="0" bIns="0" rtlCol="0" anchor="ctr"/>
           <a:lstStyle/>
           <a:p>
-            <a:pPr indent="0" marL="0">
+            <a:pPr marL="0" indent="0">
               <a:buNone/>
             </a:pPr>
             <a:r>
@@ -3262,6 +3172,13 @@
           </a:solidFill>
           <a:ln/>
         </p:spPr>
+        <p:txBody>
+          <a:bodyPr/>
+          <a:lstStyle/>
+          <a:p>
+            <a:endParaRPr lang="en-ID"/>
+          </a:p>
+        </p:txBody>
       </p:sp>
       <p:sp>
         <p:nvSpPr>
@@ -3284,7 +3201,7 @@
           <a:bodyPr wrap="square" lIns="0" tIns="0" rIns="0" bIns="0" rtlCol="0" anchor="ctr"/>
           <a:lstStyle/>
           <a:p>
-            <a:pPr algn="ctr" indent="0" marL="0">
+            <a:pPr marL="0" indent="0" algn="ctr">
               <a:buNone/>
             </a:pPr>
             <a:r>
@@ -3323,7 +3240,7 @@
           <a:bodyPr wrap="square" lIns="0" tIns="0" rIns="0" bIns="0" rtlCol="0" anchor="t"/>
           <a:lstStyle/>
           <a:p>
-            <a:pPr indent="0" marL="0">
+            <a:pPr marL="0" indent="0">
               <a:lnSpc>
                 <a:spcPct val="112000"/>
               </a:lnSpc>
@@ -3340,13 +3257,126 @@
               </a:rPr>
               <a:t>Punya Bisnis Sendiri? —  </a:t>
             </a:r>
-            <a:pPr indent="0" marL="0">
+            <a:r>
+              <a:rPr lang="en-US" sz="1250" dirty="0">
+                <a:solidFill>
+                  <a:srgbClr val="23283A"/>
+                </a:solidFill>
+                <a:latin typeface="Arial" pitchFamily="34" charset="0"/>
+                <a:ea typeface="Arial" pitchFamily="34" charset="-122"/>
+                <a:cs typeface="Arial" pitchFamily="34" charset="-120"/>
+              </a:rPr>
+              <a:t>ganti data kompetitor di cm-template-kompetitor.txt — harga, rating, ulasan terburuk 3 kompetitor nyata. Pakai contoh Dapur Rara? Lewati ke langkah 3</a:t>
+            </a:r>
+            <a:endParaRPr lang="en-US" sz="1300" dirty="0"/>
+          </a:p>
+        </p:txBody>
+      </p:sp>
+      <p:sp>
+        <p:nvSpPr>
+          <p:cNvPr id="11" name="Shape 9"/>
+          <p:cNvSpPr/>
+          <p:nvPr/>
+        </p:nvSpPr>
+        <p:spPr>
+          <a:xfrm>
+            <a:off x="548640" y="2743200"/>
+            <a:ext cx="329184" cy="329184"/>
+          </a:xfrm>
+          <a:prstGeom prst="ellipse">
+            <a:avLst/>
+          </a:prstGeom>
+          <a:solidFill>
+            <a:srgbClr val="6849F6"/>
+          </a:solidFill>
+          <a:ln/>
+        </p:spPr>
+        <p:txBody>
+          <a:bodyPr/>
+          <a:lstStyle/>
+          <a:p>
+            <a:endParaRPr lang="en-ID"/>
+          </a:p>
+        </p:txBody>
+      </p:sp>
+      <p:sp>
+        <p:nvSpPr>
+          <p:cNvPr id="12" name="Text 10"/>
+          <p:cNvSpPr/>
+          <p:nvPr/>
+        </p:nvSpPr>
+        <p:spPr>
+          <a:xfrm>
+            <a:off x="548640" y="2743200"/>
+            <a:ext cx="329184" cy="329184"/>
+          </a:xfrm>
+          <a:prstGeom prst="rect">
+            <a:avLst/>
+          </a:prstGeom>
+          <a:noFill/>
+          <a:ln/>
+        </p:spPr>
+        <p:txBody>
+          <a:bodyPr wrap="square" lIns="0" tIns="0" rIns="0" bIns="0" rtlCol="0" anchor="ctr"/>
+          <a:lstStyle/>
+          <a:p>
+            <a:pPr marL="0" indent="0" algn="ctr">
+              <a:buNone/>
+            </a:pPr>
+            <a:r>
+              <a:rPr lang="en-US" sz="1300" b="1" dirty="0">
+                <a:solidFill>
+                  <a:srgbClr val="FFFFFF"/>
+                </a:solidFill>
+                <a:latin typeface="Arial" pitchFamily="34" charset="0"/>
+                <a:ea typeface="Arial" pitchFamily="34" charset="-122"/>
+                <a:cs typeface="Arial" pitchFamily="34" charset="-120"/>
+              </a:rPr>
+              <a:t>2</a:t>
+            </a:r>
+            <a:endParaRPr lang="en-US" sz="1300" dirty="0"/>
+          </a:p>
+        </p:txBody>
+      </p:sp>
+      <p:sp>
+        <p:nvSpPr>
+          <p:cNvPr id="13" name="Text 11"/>
+          <p:cNvSpPr/>
+          <p:nvPr/>
+        </p:nvSpPr>
+        <p:spPr>
+          <a:xfrm>
+            <a:off x="1024128" y="2715768"/>
+            <a:ext cx="10616184" cy="457200"/>
+          </a:xfrm>
+          <a:prstGeom prst="rect">
+            <a:avLst/>
+          </a:prstGeom>
+          <a:noFill/>
+          <a:ln/>
+        </p:spPr>
+        <p:txBody>
+          <a:bodyPr wrap="square" lIns="0" tIns="0" rIns="0" bIns="0" rtlCol="0" anchor="t"/>
+          <a:lstStyle/>
+          <a:p>
+            <a:pPr marL="0" indent="0">
               <a:lnSpc>
                 <a:spcPct val="112000"/>
               </a:lnSpc>
               <a:buNone/>
             </a:pPr>
             <a:r>
+              <a:rPr lang="en-US" sz="1300" b="1" dirty="0">
+                <a:solidFill>
+                  <a:srgbClr val="0D1321"/>
+                </a:solidFill>
+                <a:latin typeface="Arial" pitchFamily="34" charset="0"/>
+                <a:ea typeface="Arial" pitchFamily="34" charset="-122"/>
+                <a:cs typeface="Arial" pitchFamily="34" charset="-120"/>
+              </a:rPr>
+              <a:t>Ganti Data Bisnismu —  </a:t>
+            </a:r>
+            <a:r>
               <a:rPr lang="en-US" sz="1250" dirty="0">
                 <a:solidFill>
                   <a:srgbClr val="23283A"/>
@@ -3355,7 +3385,7 @@
                 <a:ea typeface="Arial" pitchFamily="34" charset="-122"/>
                 <a:cs typeface="Arial" pitchFamily="34" charset="-120"/>
               </a:rPr>
-              <a:t>ganti data kompetitor di cm-template-kompetitor.txt — harga, rating, ulasan terburuk 3 kompetitor nyata. Pakai contoh Dapur Rara? Lewati ke langkah 3</a:t>
+              <a:t>isi juga palet warna &amp; mood visual — tanya 3 pelanggan lama kenapa mereka beli dari kamu</a:t>
             </a:r>
             <a:endParaRPr lang="en-US" sz="1300" dirty="0"/>
           </a:p>
@@ -3363,13 +3393,13 @@
       </p:sp>
       <p:sp>
         <p:nvSpPr>
-          <p:cNvPr id="11" name="Shape 9"/>
-          <p:cNvSpPr/>
-          <p:nvPr/>
-        </p:nvSpPr>
-        <p:spPr>
-          <a:xfrm>
-            <a:off x="548640" y="2743200"/>
+          <p:cNvPr id="14" name="Shape 12"/>
+          <p:cNvSpPr/>
+          <p:nvPr/>
+        </p:nvSpPr>
+        <p:spPr>
+          <a:xfrm>
+            <a:off x="548640" y="3273552"/>
             <a:ext cx="329184" cy="329184"/>
           </a:xfrm>
           <a:prstGeom prst="ellipse">
@@ -3380,16 +3410,23 @@
           </a:solidFill>
           <a:ln/>
         </p:spPr>
-      </p:sp>
-      <p:sp>
-        <p:nvSpPr>
-          <p:cNvPr id="12" name="Text 10"/>
-          <p:cNvSpPr/>
-          <p:nvPr/>
-        </p:nvSpPr>
-        <p:spPr>
-          <a:xfrm>
-            <a:off x="548640" y="2743200"/>
+        <p:txBody>
+          <a:bodyPr/>
+          <a:lstStyle/>
+          <a:p>
+            <a:endParaRPr lang="en-ID"/>
+          </a:p>
+        </p:txBody>
+      </p:sp>
+      <p:sp>
+        <p:nvSpPr>
+          <p:cNvPr id="15" name="Text 13"/>
+          <p:cNvSpPr/>
+          <p:nvPr/>
+        </p:nvSpPr>
+        <p:spPr>
+          <a:xfrm>
+            <a:off x="548640" y="3273552"/>
             <a:ext cx="329184" cy="329184"/>
           </a:xfrm>
           <a:prstGeom prst="rect">
@@ -3402,7 +3439,7 @@
           <a:bodyPr wrap="square" lIns="0" tIns="0" rIns="0" bIns="0" rtlCol="0" anchor="ctr"/>
           <a:lstStyle/>
           <a:p>
-            <a:pPr algn="ctr" indent="0" marL="0">
+            <a:pPr marL="0" indent="0" algn="ctr">
               <a:buNone/>
             </a:pPr>
             <a:r>
@@ -3414,7 +3451,7 @@
                 <a:ea typeface="Arial" pitchFamily="34" charset="-122"/>
                 <a:cs typeface="Arial" pitchFamily="34" charset="-120"/>
               </a:rPr>
-              <a:t>2</a:t>
+              <a:t>3</a:t>
             </a:r>
             <a:endParaRPr lang="en-US" sz="1300" dirty="0"/>
           </a:p>
@@ -3422,13 +3459,13 @@
       </p:sp>
       <p:sp>
         <p:nvSpPr>
-          <p:cNvPr id="13" name="Text 11"/>
-          <p:cNvSpPr/>
-          <p:nvPr/>
-        </p:nvSpPr>
-        <p:spPr>
-          <a:xfrm>
-            <a:off x="1024128" y="2715768"/>
+          <p:cNvPr id="16" name="Text 14"/>
+          <p:cNvSpPr/>
+          <p:nvPr/>
+        </p:nvSpPr>
+        <p:spPr>
+          <a:xfrm>
+            <a:off x="1024128" y="3246120"/>
             <a:ext cx="10616184" cy="457200"/>
           </a:xfrm>
           <a:prstGeom prst="rect">
@@ -3441,7 +3478,7 @@
           <a:bodyPr wrap="square" lIns="0" tIns="0" rIns="0" bIns="0" rtlCol="0" anchor="t"/>
           <a:lstStyle/>
           <a:p>
-            <a:pPr indent="0" marL="0">
+            <a:pPr marL="0" indent="0">
               <a:lnSpc>
                 <a:spcPct val="112000"/>
               </a:lnSpc>
@@ -3456,15 +3493,128 @@
                 <a:ea typeface="Arial" pitchFamily="34" charset="-122"/>
                 <a:cs typeface="Arial" pitchFamily="34" charset="-120"/>
               </a:rPr>
-              <a:t>Ganti Data Bisnismu —  </a:t>
-            </a:r>
-            <a:pPr indent="0" marL="0">
+              <a:t>Generate ke Claude —  </a:t>
+            </a:r>
+            <a:r>
+              <a:rPr lang="en-US" sz="1250" dirty="0">
+                <a:solidFill>
+                  <a:srgbClr val="23283A"/>
+                </a:solidFill>
+                <a:latin typeface="Arial" pitchFamily="34" charset="0"/>
+                <a:ea typeface="Arial" pitchFamily="34" charset="-122"/>
+                <a:cs typeface="Arial" pitchFamily="34" charset="-120"/>
+              </a:rPr>
+              <a:t>copy bagian yang ditandai PASTE KE CLAUDE saja (bukan seluruh file) — prompt sudah ada di dalamnya</a:t>
+            </a:r>
+            <a:endParaRPr lang="en-US" sz="1300" dirty="0"/>
+          </a:p>
+        </p:txBody>
+      </p:sp>
+      <p:sp>
+        <p:nvSpPr>
+          <p:cNvPr id="17" name="Shape 15"/>
+          <p:cNvSpPr/>
+          <p:nvPr/>
+        </p:nvSpPr>
+        <p:spPr>
+          <a:xfrm>
+            <a:off x="548640" y="3803904"/>
+            <a:ext cx="329184" cy="329184"/>
+          </a:xfrm>
+          <a:prstGeom prst="ellipse">
+            <a:avLst/>
+          </a:prstGeom>
+          <a:solidFill>
+            <a:srgbClr val="6849F6"/>
+          </a:solidFill>
+          <a:ln/>
+        </p:spPr>
+        <p:txBody>
+          <a:bodyPr/>
+          <a:lstStyle/>
+          <a:p>
+            <a:endParaRPr lang="en-ID"/>
+          </a:p>
+        </p:txBody>
+      </p:sp>
+      <p:sp>
+        <p:nvSpPr>
+          <p:cNvPr id="18" name="Text 16"/>
+          <p:cNvSpPr/>
+          <p:nvPr/>
+        </p:nvSpPr>
+        <p:spPr>
+          <a:xfrm>
+            <a:off x="548640" y="3803904"/>
+            <a:ext cx="329184" cy="329184"/>
+          </a:xfrm>
+          <a:prstGeom prst="rect">
+            <a:avLst/>
+          </a:prstGeom>
+          <a:noFill/>
+          <a:ln/>
+        </p:spPr>
+        <p:txBody>
+          <a:bodyPr wrap="square" lIns="0" tIns="0" rIns="0" bIns="0" rtlCol="0" anchor="ctr"/>
+          <a:lstStyle/>
+          <a:p>
+            <a:pPr marL="0" indent="0" algn="ctr">
+              <a:buNone/>
+            </a:pPr>
+            <a:r>
+              <a:rPr lang="en-US" sz="1300" b="1" dirty="0">
+                <a:solidFill>
+                  <a:srgbClr val="FFFFFF"/>
+                </a:solidFill>
+                <a:latin typeface="Arial" pitchFamily="34" charset="0"/>
+                <a:ea typeface="Arial" pitchFamily="34" charset="-122"/>
+                <a:cs typeface="Arial" pitchFamily="34" charset="-120"/>
+              </a:rPr>
+              <a:t>4</a:t>
+            </a:r>
+            <a:endParaRPr lang="en-US" sz="1300" dirty="0"/>
+          </a:p>
+        </p:txBody>
+      </p:sp>
+      <p:sp>
+        <p:nvSpPr>
+          <p:cNvPr id="19" name="Text 17"/>
+          <p:cNvSpPr/>
+          <p:nvPr/>
+        </p:nvSpPr>
+        <p:spPr>
+          <a:xfrm>
+            <a:off x="1024128" y="3776472"/>
+            <a:ext cx="10616184" cy="457200"/>
+          </a:xfrm>
+          <a:prstGeom prst="rect">
+            <a:avLst/>
+          </a:prstGeom>
+          <a:noFill/>
+          <a:ln/>
+        </p:spPr>
+        <p:txBody>
+          <a:bodyPr wrap="square" lIns="0" tIns="0" rIns="0" bIns="0" rtlCol="0" anchor="t"/>
+          <a:lstStyle/>
+          <a:p>
+            <a:pPr marL="0" indent="0">
               <a:lnSpc>
                 <a:spcPct val="112000"/>
               </a:lnSpc>
               <a:buNone/>
             </a:pPr>
             <a:r>
+              <a:rPr lang="en-US" sz="1300" b="1" dirty="0">
+                <a:solidFill>
+                  <a:srgbClr val="0D1321"/>
+                </a:solidFill>
+                <a:latin typeface="Arial" pitchFamily="34" charset="0"/>
+                <a:ea typeface="Arial" pitchFamily="34" charset="-122"/>
+                <a:cs typeface="Arial" pitchFamily="34" charset="-120"/>
+              </a:rPr>
+              <a:t>Pilih 3 Variasi Tone —  </a:t>
+            </a:r>
+            <a:r>
               <a:rPr lang="en-US" sz="1250" dirty="0">
                 <a:solidFill>
                   <a:srgbClr val="23283A"/>
@@ -3473,7 +3623,7 @@
                 <a:ea typeface="Arial" pitchFamily="34" charset="-122"/>
                 <a:cs typeface="Arial" pitchFamily="34" charset="-120"/>
               </a:rPr>
-              <a:t>isi juga palet warna &amp; mood visual — tanya 3 pelanggan lama kenapa mereka beli dari kamu</a:t>
+              <a:t>minta versi formal, santai untuk caption, dan emosional untuk iklan</a:t>
             </a:r>
             <a:endParaRPr lang="en-US" sz="1300" dirty="0"/>
           </a:p>
@@ -3481,13 +3631,13 @@
       </p:sp>
       <p:sp>
         <p:nvSpPr>
-          <p:cNvPr id="14" name="Shape 12"/>
-          <p:cNvSpPr/>
-          <p:nvPr/>
-        </p:nvSpPr>
-        <p:spPr>
-          <a:xfrm>
-            <a:off x="548640" y="3273552"/>
+          <p:cNvPr id="20" name="Shape 18"/>
+          <p:cNvSpPr/>
+          <p:nvPr/>
+        </p:nvSpPr>
+        <p:spPr>
+          <a:xfrm>
+            <a:off x="548640" y="4334256"/>
             <a:ext cx="329184" cy="329184"/>
           </a:xfrm>
           <a:prstGeom prst="ellipse">
@@ -3498,16 +3648,23 @@
           </a:solidFill>
           <a:ln/>
         </p:spPr>
-      </p:sp>
-      <p:sp>
-        <p:nvSpPr>
-          <p:cNvPr id="15" name="Text 13"/>
-          <p:cNvSpPr/>
-          <p:nvPr/>
-        </p:nvSpPr>
-        <p:spPr>
-          <a:xfrm>
-            <a:off x="548640" y="3273552"/>
+        <p:txBody>
+          <a:bodyPr/>
+          <a:lstStyle/>
+          <a:p>
+            <a:endParaRPr lang="en-ID"/>
+          </a:p>
+        </p:txBody>
+      </p:sp>
+      <p:sp>
+        <p:nvSpPr>
+          <p:cNvPr id="21" name="Text 19"/>
+          <p:cNvSpPr/>
+          <p:nvPr/>
+        </p:nvSpPr>
+        <p:spPr>
+          <a:xfrm>
+            <a:off x="548640" y="4334256"/>
             <a:ext cx="329184" cy="329184"/>
           </a:xfrm>
           <a:prstGeom prst="rect">
@@ -3520,7 +3677,7 @@
           <a:bodyPr wrap="square" lIns="0" tIns="0" rIns="0" bIns="0" rtlCol="0" anchor="ctr"/>
           <a:lstStyle/>
           <a:p>
-            <a:pPr algn="ctr" indent="0" marL="0">
+            <a:pPr marL="0" indent="0" algn="ctr">
               <a:buNone/>
             </a:pPr>
             <a:r>
@@ -3532,7 +3689,7 @@
                 <a:ea typeface="Arial" pitchFamily="34" charset="-122"/>
                 <a:cs typeface="Arial" pitchFamily="34" charset="-120"/>
               </a:rPr>
-              <a:t>3</a:t>
+              <a:t>5</a:t>
             </a:r>
             <a:endParaRPr lang="en-US" sz="1300" dirty="0"/>
           </a:p>
@@ -3540,13 +3697,13 @@
       </p:sp>
       <p:sp>
         <p:nvSpPr>
-          <p:cNvPr id="16" name="Text 14"/>
-          <p:cNvSpPr/>
-          <p:nvPr/>
-        </p:nvSpPr>
-        <p:spPr>
-          <a:xfrm>
-            <a:off x="1024128" y="3246120"/>
+          <p:cNvPr id="22" name="Text 20"/>
+          <p:cNvSpPr/>
+          <p:nvPr/>
+        </p:nvSpPr>
+        <p:spPr>
+          <a:xfrm>
+            <a:off x="1024128" y="4306824"/>
             <a:ext cx="10616184" cy="457200"/>
           </a:xfrm>
           <a:prstGeom prst="rect">
@@ -3559,7 +3716,7 @@
           <a:bodyPr wrap="square" lIns="0" tIns="0" rIns="0" bIns="0" rtlCol="0" anchor="t"/>
           <a:lstStyle/>
           <a:p>
-            <a:pPr indent="0" marL="0">
+            <a:pPr marL="0" indent="0">
               <a:lnSpc>
                 <a:spcPct val="112000"/>
               </a:lnSpc>
@@ -3574,250 +3731,8 @@
                 <a:ea typeface="Arial" pitchFamily="34" charset="-122"/>
                 <a:cs typeface="Arial" pitchFamily="34" charset="-120"/>
               </a:rPr>
-              <a:t>Generate ke Claude —  </a:t>
-            </a:r>
-            <a:pPr indent="0" marL="0">
-              <a:lnSpc>
-                <a:spcPct val="112000"/>
-              </a:lnSpc>
-              <a:buNone/>
-            </a:pPr>
-            <a:r>
-              <a:rPr lang="en-US" sz="1250" dirty="0">
-                <a:solidFill>
-                  <a:srgbClr val="23283A"/>
-                </a:solidFill>
-                <a:latin typeface="Arial" pitchFamily="34" charset="0"/>
-                <a:ea typeface="Arial" pitchFamily="34" charset="-122"/>
-                <a:cs typeface="Arial" pitchFamily="34" charset="-120"/>
-              </a:rPr>
-              <a:t>copy bagian yang ditandai PASTE KE CLAUDE saja (bukan seluruh file) — prompt sudah ada di dalamnya</a:t>
-            </a:r>
-            <a:endParaRPr lang="en-US" sz="1300" dirty="0"/>
-          </a:p>
-        </p:txBody>
-      </p:sp>
-      <p:sp>
-        <p:nvSpPr>
-          <p:cNvPr id="17" name="Shape 15"/>
-          <p:cNvSpPr/>
-          <p:nvPr/>
-        </p:nvSpPr>
-        <p:spPr>
-          <a:xfrm>
-            <a:off x="548640" y="3803904"/>
-            <a:ext cx="329184" cy="329184"/>
-          </a:xfrm>
-          <a:prstGeom prst="ellipse">
-            <a:avLst/>
-          </a:prstGeom>
-          <a:solidFill>
-            <a:srgbClr val="6849F6"/>
-          </a:solidFill>
-          <a:ln/>
-        </p:spPr>
-      </p:sp>
-      <p:sp>
-        <p:nvSpPr>
-          <p:cNvPr id="18" name="Text 16"/>
-          <p:cNvSpPr/>
-          <p:nvPr/>
-        </p:nvSpPr>
-        <p:spPr>
-          <a:xfrm>
-            <a:off x="548640" y="3803904"/>
-            <a:ext cx="329184" cy="329184"/>
-          </a:xfrm>
-          <a:prstGeom prst="rect">
-            <a:avLst/>
-          </a:prstGeom>
-          <a:noFill/>
-          <a:ln/>
-        </p:spPr>
-        <p:txBody>
-          <a:bodyPr wrap="square" lIns="0" tIns="0" rIns="0" bIns="0" rtlCol="0" anchor="ctr"/>
-          <a:lstStyle/>
-          <a:p>
-            <a:pPr algn="ctr" indent="0" marL="0">
-              <a:buNone/>
-            </a:pPr>
-            <a:r>
-              <a:rPr lang="en-US" sz="1300" b="1" dirty="0">
-                <a:solidFill>
-                  <a:srgbClr val="FFFFFF"/>
-                </a:solidFill>
-                <a:latin typeface="Arial" pitchFamily="34" charset="0"/>
-                <a:ea typeface="Arial" pitchFamily="34" charset="-122"/>
-                <a:cs typeface="Arial" pitchFamily="34" charset="-120"/>
-              </a:rPr>
-              <a:t>4</a:t>
-            </a:r>
-            <a:endParaRPr lang="en-US" sz="1300" dirty="0"/>
-          </a:p>
-        </p:txBody>
-      </p:sp>
-      <p:sp>
-        <p:nvSpPr>
-          <p:cNvPr id="19" name="Text 17"/>
-          <p:cNvSpPr/>
-          <p:nvPr/>
-        </p:nvSpPr>
-        <p:spPr>
-          <a:xfrm>
-            <a:off x="1024128" y="3776472"/>
-            <a:ext cx="10616184" cy="457200"/>
-          </a:xfrm>
-          <a:prstGeom prst="rect">
-            <a:avLst/>
-          </a:prstGeom>
-          <a:noFill/>
-          <a:ln/>
-        </p:spPr>
-        <p:txBody>
-          <a:bodyPr wrap="square" lIns="0" tIns="0" rIns="0" bIns="0" rtlCol="0" anchor="t"/>
-          <a:lstStyle/>
-          <a:p>
-            <a:pPr indent="0" marL="0">
-              <a:lnSpc>
-                <a:spcPct val="112000"/>
-              </a:lnSpc>
-              <a:buNone/>
-            </a:pPr>
-            <a:r>
-              <a:rPr lang="en-US" sz="1300" b="1" dirty="0">
-                <a:solidFill>
-                  <a:srgbClr val="0D1321"/>
-                </a:solidFill>
-                <a:latin typeface="Arial" pitchFamily="34" charset="0"/>
-                <a:ea typeface="Arial" pitchFamily="34" charset="-122"/>
-                <a:cs typeface="Arial" pitchFamily="34" charset="-120"/>
-              </a:rPr>
-              <a:t>Pilih 3 Variasi Tone —  </a:t>
-            </a:r>
-            <a:pPr indent="0" marL="0">
-              <a:lnSpc>
-                <a:spcPct val="112000"/>
-              </a:lnSpc>
-              <a:buNone/>
-            </a:pPr>
-            <a:r>
-              <a:rPr lang="en-US" sz="1250" dirty="0">
-                <a:solidFill>
-                  <a:srgbClr val="23283A"/>
-                </a:solidFill>
-                <a:latin typeface="Arial" pitchFamily="34" charset="0"/>
-                <a:ea typeface="Arial" pitchFamily="34" charset="-122"/>
-                <a:cs typeface="Arial" pitchFamily="34" charset="-120"/>
-              </a:rPr>
-              <a:t>minta versi formal, santai untuk caption, dan emosional untuk iklan</a:t>
-            </a:r>
-            <a:endParaRPr lang="en-US" sz="1300" dirty="0"/>
-          </a:p>
-        </p:txBody>
-      </p:sp>
-      <p:sp>
-        <p:nvSpPr>
-          <p:cNvPr id="20" name="Shape 18"/>
-          <p:cNvSpPr/>
-          <p:nvPr/>
-        </p:nvSpPr>
-        <p:spPr>
-          <a:xfrm>
-            <a:off x="548640" y="4334256"/>
-            <a:ext cx="329184" cy="329184"/>
-          </a:xfrm>
-          <a:prstGeom prst="ellipse">
-            <a:avLst/>
-          </a:prstGeom>
-          <a:solidFill>
-            <a:srgbClr val="6849F6"/>
-          </a:solidFill>
-          <a:ln/>
-        </p:spPr>
-      </p:sp>
-      <p:sp>
-        <p:nvSpPr>
-          <p:cNvPr id="21" name="Text 19"/>
-          <p:cNvSpPr/>
-          <p:nvPr/>
-        </p:nvSpPr>
-        <p:spPr>
-          <a:xfrm>
-            <a:off x="548640" y="4334256"/>
-            <a:ext cx="329184" cy="329184"/>
-          </a:xfrm>
-          <a:prstGeom prst="rect">
-            <a:avLst/>
-          </a:prstGeom>
-          <a:noFill/>
-          <a:ln/>
-        </p:spPr>
-        <p:txBody>
-          <a:bodyPr wrap="square" lIns="0" tIns="0" rIns="0" bIns="0" rtlCol="0" anchor="ctr"/>
-          <a:lstStyle/>
-          <a:p>
-            <a:pPr algn="ctr" indent="0" marL="0">
-              <a:buNone/>
-            </a:pPr>
-            <a:r>
-              <a:rPr lang="en-US" sz="1300" b="1" dirty="0">
-                <a:solidFill>
-                  <a:srgbClr val="FFFFFF"/>
-                </a:solidFill>
-                <a:latin typeface="Arial" pitchFamily="34" charset="0"/>
-                <a:ea typeface="Arial" pitchFamily="34" charset="-122"/>
-                <a:cs typeface="Arial" pitchFamily="34" charset="-120"/>
-              </a:rPr>
-              <a:t>5</a:t>
-            </a:r>
-            <a:endParaRPr lang="en-US" sz="1300" dirty="0"/>
-          </a:p>
-        </p:txBody>
-      </p:sp>
-      <p:sp>
-        <p:nvSpPr>
-          <p:cNvPr id="22" name="Text 20"/>
-          <p:cNvSpPr/>
-          <p:nvPr/>
-        </p:nvSpPr>
-        <p:spPr>
-          <a:xfrm>
-            <a:off x="1024128" y="4306824"/>
-            <a:ext cx="10616184" cy="457200"/>
-          </a:xfrm>
-          <a:prstGeom prst="rect">
-            <a:avLst/>
-          </a:prstGeom>
-          <a:noFill/>
-          <a:ln/>
-        </p:spPr>
-        <p:txBody>
-          <a:bodyPr wrap="square" lIns="0" tIns="0" rIns="0" bIns="0" rtlCol="0" anchor="t"/>
-          <a:lstStyle/>
-          <a:p>
-            <a:pPr indent="0" marL="0">
-              <a:lnSpc>
-                <a:spcPct val="112000"/>
-              </a:lnSpc>
-              <a:buNone/>
-            </a:pPr>
-            <a:r>
-              <a:rPr lang="en-US" sz="1300" b="1" dirty="0">
-                <a:solidFill>
-                  <a:srgbClr val="0D1321"/>
-                </a:solidFill>
-                <a:latin typeface="Arial" pitchFamily="34" charset="0"/>
-                <a:ea typeface="Arial" pitchFamily="34" charset="-122"/>
-                <a:cs typeface="Arial" pitchFamily="34" charset="-120"/>
-              </a:rPr>
               <a:t>Simpan di Claude Projects —  </a:t>
             </a:r>
-            <a:pPr indent="0" marL="0">
-              <a:lnSpc>
-                <a:spcPct val="112000"/>
-              </a:lnSpc>
-              <a:buNone/>
-            </a:pPr>
             <a:r>
               <a:rPr lang="en-US" sz="1250" dirty="0">
                 <a:solidFill>
@@ -3859,6 +3774,13 @@
             <a:prstDash val="solid"/>
           </a:ln>
         </p:spPr>
+        <p:txBody>
+          <a:bodyPr/>
+          <a:lstStyle/>
+          <a:p>
+            <a:endParaRPr lang="en-ID"/>
+          </a:p>
+        </p:txBody>
       </p:sp>
       <p:sp>
         <p:nvSpPr>
@@ -3881,7 +3803,7 @@
           <a:bodyPr wrap="square" lIns="0" tIns="0" rIns="0" bIns="0" rtlCol="0" anchor="ctr"/>
           <a:lstStyle/>
           <a:p>
-            <a:pPr indent="0" marL="0">
+            <a:pPr marL="0" indent="0">
               <a:lnSpc>
                 <a:spcPct val="120000"/>
               </a:lnSpc>
@@ -3898,12 +3820,6 @@
               </a:rPr>
               <a:t>◆  KENAPA WARNA DAN MOOD JUGA DISIMPAN?  </a:t>
             </a:r>
-            <a:pPr indent="0" marL="0">
-              <a:lnSpc>
-                <a:spcPct val="120000"/>
-              </a:lnSpc>
-              <a:buNone/>
-            </a:pPr>
             <a:r>
               <a:rPr lang="en-US" sz="1200" dirty="0">
                 <a:solidFill>
@@ -3935,6 +3851,7 @@
         <a:solidFill>
           <a:srgbClr val="FFFFFF"/>
         </a:solidFill>
+        <a:effectLst/>
       </p:bgPr>
     </p:bg>
     <p:spTree>
@@ -3970,6 +3887,13 @@
           </a:solidFill>
           <a:ln/>
         </p:spPr>
+        <p:txBody>
+          <a:bodyPr/>
+          <a:lstStyle/>
+          <a:p>
+            <a:endParaRPr lang="en-ID"/>
+          </a:p>
+        </p:txBody>
       </p:sp>
       <p:sp>
         <p:nvSpPr>
@@ -3990,6 +3914,13 @@
           </a:solidFill>
           <a:ln/>
         </p:spPr>
+        <p:txBody>
+          <a:bodyPr/>
+          <a:lstStyle/>
+          <a:p>
+            <a:endParaRPr lang="en-ID"/>
+          </a:p>
+        </p:txBody>
       </p:sp>
       <p:sp>
         <p:nvSpPr>
@@ -4012,7 +3943,7 @@
           <a:bodyPr wrap="square" lIns="0" tIns="0" rIns="0" bIns="0" rtlCol="0" anchor="ctr"/>
           <a:lstStyle/>
           <a:p>
-            <a:pPr indent="0" marL="0">
+            <a:pPr marL="0" indent="0">
               <a:buNone/>
             </a:pPr>
             <a:r>
@@ -4026,9 +3957,6 @@
               </a:rPr>
               <a:t>belajar</a:t>
             </a:r>
-            <a:pPr indent="0" marL="0">
-              <a:buNone/>
-            </a:pPr>
             <a:r>
               <a:rPr lang="en-US" sz="2000" b="1" dirty="0">
                 <a:solidFill>
@@ -4065,7 +3993,7 @@
           <a:bodyPr wrap="square" lIns="0" tIns="0" rIns="0" bIns="0" rtlCol="0" anchor="ctr"/>
           <a:lstStyle/>
           <a:p>
-            <a:pPr algn="r" indent="0" marL="0">
+            <a:pPr marL="0" indent="0" algn="r">
               <a:buNone/>
             </a:pPr>
             <a:r>
@@ -4104,11 +4032,11 @@
           <a:bodyPr wrap="square" lIns="0" tIns="0" rIns="0" bIns="0" rtlCol="0" anchor="ctr"/>
           <a:lstStyle/>
           <a:p>
-            <a:pPr indent="0" marL="0">
-              <a:buNone/>
-            </a:pPr>
-            <a:r>
-              <a:rPr lang="en-US" sz="1250" b="1" spc="100" kern="0" dirty="0">
+            <a:pPr marL="0" indent="0">
+              <a:buNone/>
+            </a:pPr>
+            <a:r>
+              <a:rPr lang="en-US" sz="1250" b="1" kern="0" spc="100" dirty="0">
                 <a:solidFill>
                   <a:srgbClr val="4B36C7"/>
                 </a:solidFill>
@@ -4143,7 +4071,7 @@
           <a:bodyPr wrap="square" lIns="0" tIns="0" rIns="0" bIns="0" rtlCol="0" anchor="ctr"/>
           <a:lstStyle/>
           <a:p>
-            <a:pPr indent="0" marL="0">
+            <a:pPr marL="0" indent="0">
               <a:buNone/>
             </a:pPr>
             <a:r>
@@ -4187,6 +4115,13 @@
             <a:prstDash val="solid"/>
           </a:ln>
         </p:spPr>
+        <p:txBody>
+          <a:bodyPr/>
+          <a:lstStyle/>
+          <a:p>
+            <a:endParaRPr lang="en-ID"/>
+          </a:p>
+        </p:txBody>
       </p:sp>
       <p:sp>
         <p:nvSpPr>
@@ -4209,11 +4144,11 @@
           <a:bodyPr wrap="square" lIns="0" tIns="0" rIns="0" bIns="0" rtlCol="0" anchor="ctr"/>
           <a:lstStyle/>
           <a:p>
-            <a:pPr indent="0" marL="0">
-              <a:buNone/>
-            </a:pPr>
-            <a:r>
-              <a:rPr lang="en-US" sz="1250" b="1" spc="50" kern="0" dirty="0">
+            <a:pPr marL="0" indent="0">
+              <a:buNone/>
+            </a:pPr>
+            <a:r>
+              <a:rPr lang="en-US" sz="1250" b="1" kern="0" spc="50" dirty="0">
                 <a:solidFill>
                   <a:srgbClr val="1A7A44"/>
                 </a:solidFill>
@@ -4248,7 +4183,7 @@
           <a:bodyPr wrap="square" lIns="0" tIns="0" rIns="0" bIns="0" rtlCol="0" anchor="t"/>
           <a:lstStyle/>
           <a:p>
-            <a:pPr indent="0" marL="0">
+            <a:pPr marL="0" indent="0">
               <a:lnSpc>
                 <a:spcPct val="125000"/>
               </a:lnSpc>
@@ -4295,6 +4230,13 @@
             <a:prstDash val="solid"/>
           </a:ln>
         </p:spPr>
+        <p:txBody>
+          <a:bodyPr/>
+          <a:lstStyle/>
+          <a:p>
+            <a:endParaRPr lang="en-ID"/>
+          </a:p>
+        </p:txBody>
       </p:sp>
       <p:sp>
         <p:nvSpPr>
@@ -4317,11 +4259,11 @@
           <a:bodyPr wrap="square" lIns="0" tIns="0" rIns="0" bIns="0" rtlCol="0" anchor="ctr"/>
           <a:lstStyle/>
           <a:p>
-            <a:pPr indent="0" marL="0">
-              <a:buNone/>
-            </a:pPr>
-            <a:r>
-              <a:rPr lang="en-US" sz="1250" b="1" spc="50" kern="0" dirty="0">
+            <a:pPr marL="0" indent="0">
+              <a:buNone/>
+            </a:pPr>
+            <a:r>
+              <a:rPr lang="en-US" sz="1250" b="1" kern="0" spc="50" dirty="0">
                 <a:solidFill>
                   <a:srgbClr val="8B7CF6"/>
                 </a:solidFill>
@@ -4356,7 +4298,7 @@
           <a:bodyPr wrap="square" lIns="0" tIns="0" rIns="0" bIns="0" rtlCol="0" anchor="t"/>
           <a:lstStyle/>
           <a:p>
-            <a:pPr indent="0" marL="0">
+            <a:pPr marL="0" indent="0">
               <a:lnSpc>
                 <a:spcPct val="125000"/>
               </a:lnSpc>
@@ -4376,7 +4318,7 @@
             <a:endParaRPr lang="en-US" sz="1250" dirty="0"/>
           </a:p>
           <a:p>
-            <a:pPr indent="0" marL="0">
+            <a:pPr marL="0" indent="0">
               <a:lnSpc>
                 <a:spcPct val="125000"/>
               </a:lnSpc>
@@ -4385,7 +4327,7 @@
             <a:endParaRPr lang="en-US" sz="1250" dirty="0"/>
           </a:p>
           <a:p>
-            <a:pPr indent="0" marL="0">
+            <a:pPr marL="0" indent="0">
               <a:lnSpc>
                 <a:spcPct val="125000"/>
               </a:lnSpc>
@@ -4707,4 +4649,319 @@
     </a:ext>
   </a:extLst>
 </a:theme>
+</file>
+
+<file path=ppt/theme/theme2.xml><?xml version="1.0" encoding="utf-8"?>
+<a:theme xmlns:a="http://schemas.openxmlformats.org/drawingml/2006/main" name="Office Theme">
+  <a:themeElements>
+    <a:clrScheme name="Office">
+      <a:dk1>
+        <a:sysClr val="windowText" lastClr="000000"/>
+      </a:dk1>
+      <a:lt1>
+        <a:sysClr val="window" lastClr="FFFFFF"/>
+      </a:lt1>
+      <a:dk2>
+        <a:srgbClr val="0E2841"/>
+      </a:dk2>
+      <a:lt2>
+        <a:srgbClr val="E8E8E8"/>
+      </a:lt2>
+      <a:accent1>
+        <a:srgbClr val="156082"/>
+      </a:accent1>
+      <a:accent2>
+        <a:srgbClr val="E97132"/>
+      </a:accent2>
+      <a:accent3>
+        <a:srgbClr val="196B24"/>
+      </a:accent3>
+      <a:accent4>
+        <a:srgbClr val="0F9ED5"/>
+      </a:accent4>
+      <a:accent5>
+        <a:srgbClr val="A02B93"/>
+      </a:accent5>
+      <a:accent6>
+        <a:srgbClr val="4EA72E"/>
+      </a:accent6>
+      <a:hlink>
+        <a:srgbClr val="467886"/>
+      </a:hlink>
+      <a:folHlink>
+        <a:srgbClr val="96607D"/>
+      </a:folHlink>
+    </a:clrScheme>
+    <a:fontScheme name="Office">
+      <a:majorFont>
+        <a:latin typeface="Aptos Display" panose="02110004020202020204"/>
+        <a:ea typeface=""/>
+        <a:cs typeface=""/>
+        <a:font script="Jpan" typeface="游ゴシック Light"/>
+        <a:font script="Hang" typeface="맑은 고딕"/>
+        <a:font script="Hans" typeface="等线 Light"/>
+        <a:font script="Hant" typeface="新細明體"/>
+        <a:font script="Arab" typeface="Times New Roman"/>
+        <a:font script="Hebr" typeface="Times New Roman"/>
+        <a:font script="Thai" typeface="Angsana New"/>
+        <a:font script="Ethi" typeface="Nyala"/>
+        <a:font script="Beng" typeface="Vrinda"/>
+        <a:font script="Gujr" typeface="Shruti"/>
+        <a:font script="Khmr" typeface="MoolBoran"/>
+        <a:font script="Knda" typeface="Tunga"/>
+        <a:font script="Guru" typeface="Raavi"/>
+        <a:font script="Cans" typeface="Euphemia"/>
+        <a:font script="Cher" typeface="Plantagenet Cherokee"/>
+        <a:font script="Yiii" typeface="Microsoft Yi Baiti"/>
+        <a:font script="Tibt" typeface="Microsoft Himalaya"/>
+        <a:font script="Thaa" typeface="MV Boli"/>
+        <a:font script="Deva" typeface="Mangal"/>
+        <a:font script="Telu" typeface="Gautami"/>
+        <a:font script="Taml" typeface="Latha"/>
+        <a:font script="Syrc" typeface="Estrangelo Edessa"/>
+        <a:font script="Orya" typeface="Kalinga"/>
+        <a:font script="Mlym" typeface="Kartika"/>
+        <a:font script="Laoo" typeface="DokChampa"/>
+        <a:font script="Sinh" typeface="Iskoola Pota"/>
+        <a:font script="Mong" typeface="Mongolian Baiti"/>
+        <a:font script="Viet" typeface="Times New Roman"/>
+        <a:font script="Uigh" typeface="Microsoft Uighur"/>
+        <a:font script="Geor" typeface="Sylfaen"/>
+        <a:font script="Armn" typeface="Arial"/>
+        <a:font script="Bugi" typeface="Leelawadee UI"/>
+        <a:font script="Bopo" typeface="Microsoft JhengHei"/>
+        <a:font script="Java" typeface="Javanese Text"/>
+        <a:font script="Lisu" typeface="Segoe UI"/>
+        <a:font script="Mymr" typeface="Myanmar Text"/>
+        <a:font script="Nkoo" typeface="Ebrima"/>
+        <a:font script="Olck" typeface="Nirmala UI"/>
+        <a:font script="Osma" typeface="Ebrima"/>
+        <a:font script="Phag" typeface="Phagspa"/>
+        <a:font script="Syrn" typeface="Estrangelo Edessa"/>
+        <a:font script="Syrj" typeface="Estrangelo Edessa"/>
+        <a:font script="Syre" typeface="Estrangelo Edessa"/>
+        <a:font script="Sora" typeface="Nirmala UI"/>
+        <a:font script="Tale" typeface="Microsoft Tai Le"/>
+        <a:font script="Talu" typeface="Microsoft New Tai Lue"/>
+        <a:font script="Tfng" typeface="Ebrima"/>
+      </a:majorFont>
+      <a:minorFont>
+        <a:latin typeface="Aptos" panose="02110004020202020204"/>
+        <a:ea typeface=""/>
+        <a:cs typeface=""/>
+        <a:font script="Jpan" typeface="游ゴシック"/>
+        <a:font script="Hang" typeface="맑은 고딕"/>
+        <a:font script="Hans" typeface="等线"/>
+        <a:font script="Hant" typeface="新細明體"/>
+        <a:font script="Arab" typeface="Arial"/>
+        <a:font script="Hebr" typeface="Arial"/>
+        <a:font script="Thai" typeface="Cordia New"/>
+        <a:font script="Ethi" typeface="Nyala"/>
+        <a:font script="Beng" typeface="Vrinda"/>
+        <a:font script="Gujr" typeface="Shruti"/>
+        <a:font script="Khmr" typeface="DaunPenh"/>
+        <a:font script="Knda" typeface="Tunga"/>
+        <a:font script="Guru" typeface="Raavi"/>
+        <a:font script="Cans" typeface="Euphemia"/>
+        <a:font script="Cher" typeface="Plantagenet Cherokee"/>
+        <a:font script="Yiii" typeface="Microsoft Yi Baiti"/>
+        <a:font script="Tibt" typeface="Microsoft Himalaya"/>
+        <a:font script="Thaa" typeface="MV Boli"/>
+        <a:font script="Deva" typeface="Mangal"/>
+        <a:font script="Telu" typeface="Gautami"/>
+        <a:font script="Taml" typeface="Latha"/>
+        <a:font script="Syrc" typeface="Estrangelo Edessa"/>
+        <a:font script="Orya" typeface="Kalinga"/>
+        <a:font script="Mlym" typeface="Kartika"/>
+        <a:font script="Laoo" typeface="DokChampa"/>
+        <a:font script="Sinh" typeface="Iskoola Pota"/>
+        <a:font script="Mong" typeface="Mongolian Baiti"/>
+        <a:font script="Viet" typeface="Arial"/>
+        <a:font script="Uigh" typeface="Microsoft Uighur"/>
+        <a:font script="Geor" typeface="Sylfaen"/>
+        <a:font script="Armn" typeface="Arial"/>
+        <a:font script="Bugi" typeface="Leelawadee UI"/>
+        <a:font script="Bopo" typeface="Microsoft JhengHei"/>
+        <a:font script="Java" typeface="Javanese Text"/>
+        <a:font script="Lisu" typeface="Segoe UI"/>
+        <a:font script="Mymr" typeface="Myanmar Text"/>
+        <a:font script="Nkoo" typeface="Ebrima"/>
+        <a:font script="Olck" typeface="Nirmala UI"/>
+        <a:font script="Osma" typeface="Ebrima"/>
+        <a:font script="Phag" typeface="Phagspa"/>
+        <a:font script="Syrn" typeface="Estrangelo Edessa"/>
+        <a:font script="Syrj" typeface="Estrangelo Edessa"/>
+        <a:font script="Syre" typeface="Estrangelo Edessa"/>
+        <a:font script="Sora" typeface="Nirmala UI"/>
+        <a:font script="Tale" typeface="Microsoft Tai Le"/>
+        <a:font script="Talu" typeface="Microsoft New Tai Lue"/>
+        <a:font script="Tfng" typeface="Ebrima"/>
+      </a:minorFont>
+    </a:fontScheme>
+    <a:fmtScheme name="Office">
+      <a:fillStyleLst>
+        <a:solidFill>
+          <a:schemeClr val="phClr"/>
+        </a:solidFill>
+        <a:gradFill rotWithShape="1">
+          <a:gsLst>
+            <a:gs pos="0">
+              <a:schemeClr val="phClr">
+                <a:lumMod val="110000"/>
+                <a:satMod val="105000"/>
+                <a:tint val="67000"/>
+              </a:schemeClr>
+            </a:gs>
+            <a:gs pos="50000">
+              <a:schemeClr val="phClr">
+                <a:lumMod val="105000"/>
+                <a:satMod val="103000"/>
+                <a:tint val="73000"/>
+              </a:schemeClr>
+            </a:gs>
+            <a:gs pos="100000">
+              <a:schemeClr val="phClr">
+                <a:lumMod val="105000"/>
+                <a:satMod val="109000"/>
+                <a:tint val="81000"/>
+              </a:schemeClr>
+            </a:gs>
+          </a:gsLst>
+          <a:lin ang="5400000" scaled="0"/>
+        </a:gradFill>
+        <a:gradFill rotWithShape="1">
+          <a:gsLst>
+            <a:gs pos="0">
+              <a:schemeClr val="phClr">
+                <a:satMod val="103000"/>
+                <a:lumMod val="102000"/>
+                <a:tint val="94000"/>
+              </a:schemeClr>
+            </a:gs>
+            <a:gs pos="50000">
+              <a:schemeClr val="phClr">
+                <a:satMod val="110000"/>
+                <a:lumMod val="100000"/>
+                <a:shade val="100000"/>
+              </a:schemeClr>
+            </a:gs>
+            <a:gs pos="100000">
+              <a:schemeClr val="phClr">
+                <a:lumMod val="99000"/>
+                <a:satMod val="120000"/>
+                <a:shade val="78000"/>
+              </a:schemeClr>
+            </a:gs>
+          </a:gsLst>
+          <a:lin ang="5400000" scaled="0"/>
+        </a:gradFill>
+      </a:fillStyleLst>
+      <a:lnStyleLst>
+        <a:ln w="12700" cap="flat" cmpd="sng" algn="ctr">
+          <a:solidFill>
+            <a:schemeClr val="phClr"/>
+          </a:solidFill>
+          <a:prstDash val="solid"/>
+          <a:miter lim="800000"/>
+        </a:ln>
+        <a:ln w="19050" cap="flat" cmpd="sng" algn="ctr">
+          <a:solidFill>
+            <a:schemeClr val="phClr"/>
+          </a:solidFill>
+          <a:prstDash val="solid"/>
+          <a:miter lim="800000"/>
+        </a:ln>
+        <a:ln w="25400" cap="flat" cmpd="sng" algn="ctr">
+          <a:solidFill>
+            <a:schemeClr val="phClr"/>
+          </a:solidFill>
+          <a:prstDash val="solid"/>
+          <a:miter lim="800000"/>
+        </a:ln>
+      </a:lnStyleLst>
+      <a:effectStyleLst>
+        <a:effectStyle>
+          <a:effectLst/>
+        </a:effectStyle>
+        <a:effectStyle>
+          <a:effectLst/>
+        </a:effectStyle>
+        <a:effectStyle>
+          <a:effectLst>
+            <a:outerShdw blurRad="57150" dist="19050" dir="5400000" algn="ctr" rotWithShape="0">
+              <a:srgbClr val="000000">
+                <a:alpha val="63000"/>
+              </a:srgbClr>
+            </a:outerShdw>
+          </a:effectLst>
+        </a:effectStyle>
+      </a:effectStyleLst>
+      <a:bgFillStyleLst>
+        <a:solidFill>
+          <a:schemeClr val="phClr"/>
+        </a:solidFill>
+        <a:solidFill>
+          <a:schemeClr val="phClr">
+            <a:tint val="95000"/>
+            <a:satMod val="170000"/>
+          </a:schemeClr>
+        </a:solidFill>
+        <a:gradFill rotWithShape="1">
+          <a:gsLst>
+            <a:gs pos="0">
+              <a:schemeClr val="phClr">
+                <a:tint val="93000"/>
+                <a:satMod val="150000"/>
+                <a:shade val="98000"/>
+                <a:lumMod val="102000"/>
+              </a:schemeClr>
+            </a:gs>
+            <a:gs pos="50000">
+              <a:schemeClr val="phClr">
+                <a:tint val="98000"/>
+                <a:satMod val="130000"/>
+                <a:shade val="90000"/>
+                <a:lumMod val="103000"/>
+              </a:schemeClr>
+            </a:gs>
+            <a:gs pos="100000">
+              <a:schemeClr val="phClr">
+                <a:shade val="63000"/>
+                <a:satMod val="120000"/>
+              </a:schemeClr>
+            </a:gs>
+          </a:gsLst>
+          <a:lin ang="5400000" scaled="0"/>
+        </a:gradFill>
+      </a:bgFillStyleLst>
+    </a:fmtScheme>
+  </a:themeElements>
+  <a:objectDefaults>
+    <a:lnDef>
+      <a:spPr/>
+      <a:bodyPr/>
+      <a:lstStyle/>
+      <a:style>
+        <a:lnRef idx="2">
+          <a:schemeClr val="accent1"/>
+        </a:lnRef>
+        <a:fillRef idx="0">
+          <a:schemeClr val="accent1"/>
+        </a:fillRef>
+        <a:effectRef idx="1">
+          <a:schemeClr val="accent1"/>
+        </a:effectRef>
+        <a:fontRef idx="minor">
+          <a:schemeClr val="tx1"/>
+        </a:fontRef>
+      </a:style>
+    </a:lnDef>
+  </a:objectDefaults>
+  <a:extraClrSchemeLst/>
+  <a:extLst>
+    <a:ext uri="{05A4C25C-085E-4340-85A3-A5531E510DB2}">
+      <thm15:themeFamily xmlns:thm15="http://schemas.microsoft.com/office/thememl/2012/main" name="Office Theme" id="{2E142A2C-CD16-42D6-873A-C26D2A0506FA}" vid="{1BDDFF52-6CD6-40A5-AB3C-68EB2F1E4D0A}"/>
+    </a:ext>
+  </a:extLst>
+</a:theme>
 </file>
</xml_diff>